<commit_message>
feat(ppt): upgrade SIH presentation to military-grade dark theme across all 6 slides
</commit_message>
<xml_diff>
--- a/INDRA_SIH_Winning_Deck_6_Slides.pptx
+++ b/INDRA_SIH_Winning_Deck_6_Slides.pptx
@@ -3108,7 +3108,7 @@
             <a:avLst/>
           </a:prstGeom>
           <a:solidFill>
-            <a:srgbClr val="0A192F"/>
+            <a:srgbClr val="070F1E"/>
           </a:solidFill>
           <a:ln>
             <a:noFill/>
@@ -3144,7 +3144,7 @@
         </p:nvSpPr>
         <p:spPr>
           <a:xfrm>
-            <a:off x="914400" y="731520"/>
+            <a:off x="914400" y="640080"/>
             <a:ext cx="10362895" cy="365760"/>
           </a:xfrm>
           <a:prstGeom prst="rect">
@@ -3179,7 +3179,7 @@
         </p:nvSpPr>
         <p:spPr>
           <a:xfrm>
-            <a:off x="914400" y="1188720"/>
+            <a:off x="914400" y="1097280"/>
             <a:ext cx="10362895" cy="1645920"/>
           </a:xfrm>
           <a:prstGeom prst="rect">
@@ -3226,14 +3226,14 @@
         </p:nvSpPr>
         <p:spPr>
           <a:xfrm>
-            <a:off x="914400" y="3017520"/>
-            <a:ext cx="3291840" cy="1371600"/>
+            <a:off x="914400" y="2971800"/>
+            <a:ext cx="3291840" cy="1417320"/>
           </a:xfrm>
           <a:prstGeom prst="roundRect">
             <a:avLst/>
           </a:prstGeom>
           <a:solidFill>
-            <a:srgbClr val="0F172A"/>
+            <a:srgbClr val="172541"/>
           </a:solidFill>
           <a:ln w="19050">
             <a:solidFill>
@@ -3271,8 +3271,8 @@
         </p:nvSpPr>
         <p:spPr>
           <a:xfrm>
-            <a:off x="1097280" y="3154680"/>
-            <a:ext cx="2926080" cy="1097280"/>
+            <a:off x="1051560" y="3081528"/>
+            <a:ext cx="3017520" cy="1197864"/>
           </a:xfrm>
           <a:prstGeom prst="rect">
             <a:avLst/>
@@ -3280,13 +3280,13 @@
           <a:noFill/>
         </p:spPr>
         <p:txBody>
-          <a:bodyPr wrap="square">
+          <a:bodyPr wrap="square" lIns="0" tIns="0" rIns="0" bIns="0">
             <a:spAutoFit/>
           </a:bodyPr>
           <a:lstStyle/>
           <a:p>
             <a:pPr>
-              <a:defRPr b="1" sz="950">
+              <a:defRPr b="1" sz="900">
                 <a:solidFill>
                   <a:srgbClr val="38BDF8"/>
                 </a:solidFill>
@@ -3298,7 +3298,7 @@
           </a:p>
           <a:p>
             <a:pPr>
-              <a:defRPr b="1" sz="1800">
+              <a:defRPr b="1" sz="1700">
                 <a:solidFill>
                   <a:srgbClr val="FFFFFF"/>
                 </a:solidFill>
@@ -3312,12 +3312,12 @@
             <a:pPr>
               <a:defRPr sz="850">
                 <a:solidFill>
-                  <a:srgbClr val="CBD5E1"/>
-                </a:solidFill>
-              </a:defRPr>
-            </a:pPr>
-            <a:r>
-              <a:t>Theme: Smart Automation • Software Category</a:t>
+                  <a:srgbClr val="94A3B8"/>
+                </a:solidFill>
+              </a:defRPr>
+            </a:pPr>
+            <a:r>
+              <a:t>Theme: Smart Automation • Category: Software</a:t>
             </a:r>
           </a:p>
         </p:txBody>
@@ -3330,18 +3330,18 @@
         </p:nvSpPr>
         <p:spPr>
           <a:xfrm>
-            <a:off x="4480560" y="3017520"/>
-            <a:ext cx="3291840" cy="1371600"/>
+            <a:off x="4480560" y="2971800"/>
+            <a:ext cx="3291840" cy="1417320"/>
           </a:xfrm>
           <a:prstGeom prst="roundRect">
             <a:avLst/>
           </a:prstGeom>
           <a:solidFill>
-            <a:srgbClr val="0F172A"/>
+            <a:srgbClr val="172541"/>
           </a:solidFill>
           <a:ln w="19050">
             <a:solidFill>
-              <a:srgbClr val="059669"/>
+              <a:srgbClr val="10B981"/>
             </a:solidFill>
           </a:ln>
         </p:spPr>
@@ -3375,8 +3375,8 @@
         </p:nvSpPr>
         <p:spPr>
           <a:xfrm>
-            <a:off x="4663440" y="3154680"/>
-            <a:ext cx="2926080" cy="1097280"/>
+            <a:off x="4617720" y="3081528"/>
+            <a:ext cx="3017520" cy="1197864"/>
           </a:xfrm>
           <a:prstGeom prst="rect">
             <a:avLst/>
@@ -3384,15 +3384,15 @@
           <a:noFill/>
         </p:spPr>
         <p:txBody>
-          <a:bodyPr wrap="square">
+          <a:bodyPr wrap="square" lIns="0" tIns="0" rIns="0" bIns="0">
             <a:spAutoFit/>
           </a:bodyPr>
           <a:lstStyle/>
           <a:p>
             <a:pPr>
-              <a:defRPr b="1" sz="950">
-                <a:solidFill>
-                  <a:srgbClr val="059669"/>
+              <a:defRPr b="1" sz="900">
+                <a:solidFill>
+                  <a:srgbClr val="10B981"/>
                 </a:solidFill>
               </a:defRPr>
             </a:pPr>
@@ -3402,7 +3402,7 @@
           </a:p>
           <a:p>
             <a:pPr>
-              <a:defRPr b="1" sz="1800">
+              <a:defRPr b="1" sz="1700">
                 <a:solidFill>
                   <a:srgbClr val="FFFFFF"/>
                 </a:solidFill>
@@ -3416,7 +3416,7 @@
             <a:pPr>
               <a:defRPr sz="850">
                 <a:solidFill>
-                  <a:srgbClr val="CBD5E1"/>
+                  <a:srgbClr val="94A3B8"/>
                 </a:solidFill>
               </a:defRPr>
             </a:pPr>
@@ -3434,18 +3434,18 @@
         </p:nvSpPr>
         <p:spPr>
           <a:xfrm>
-            <a:off x="8046720" y="3017520"/>
-            <a:ext cx="3291840" cy="1371600"/>
+            <a:off x="8046720" y="2971800"/>
+            <a:ext cx="3291840" cy="1417320"/>
           </a:xfrm>
           <a:prstGeom prst="roundRect">
             <a:avLst/>
           </a:prstGeom>
           <a:solidFill>
-            <a:srgbClr val="0F172A"/>
+            <a:srgbClr val="172541"/>
           </a:solidFill>
           <a:ln w="19050">
             <a:solidFill>
-              <a:srgbClr val="D97706"/>
+              <a:srgbClr val="F59E0B"/>
             </a:solidFill>
           </a:ln>
         </p:spPr>
@@ -3479,8 +3479,8 @@
         </p:nvSpPr>
         <p:spPr>
           <a:xfrm>
-            <a:off x="8229600" y="3154680"/>
-            <a:ext cx="2926080" cy="1097280"/>
+            <a:off x="8183880" y="3081528"/>
+            <a:ext cx="3017520" cy="1197864"/>
           </a:xfrm>
           <a:prstGeom prst="rect">
             <a:avLst/>
@@ -3488,15 +3488,15 @@
           <a:noFill/>
         </p:spPr>
         <p:txBody>
-          <a:bodyPr wrap="square">
+          <a:bodyPr wrap="square" lIns="0" tIns="0" rIns="0" bIns="0">
             <a:spAutoFit/>
           </a:bodyPr>
           <a:lstStyle/>
           <a:p>
             <a:pPr>
-              <a:defRPr b="1" sz="950">
-                <a:solidFill>
-                  <a:srgbClr val="D97706"/>
+              <a:defRPr b="1" sz="900">
+                <a:solidFill>
+                  <a:srgbClr val="F59E0B"/>
                 </a:solidFill>
               </a:defRPr>
             </a:pPr>
@@ -3506,7 +3506,7 @@
           </a:p>
           <a:p>
             <a:pPr>
-              <a:defRPr b="1" sz="1800">
+              <a:defRPr b="1" sz="1700">
                 <a:solidFill>
                   <a:srgbClr val="FFFFFF"/>
                 </a:solidFill>
@@ -3520,7 +3520,7 @@
             <a:pPr>
               <a:defRPr sz="850">
                 <a:solidFill>
-                  <a:srgbClr val="CBD5E1"/>
+                  <a:srgbClr val="94A3B8"/>
                 </a:solidFill>
               </a:defRPr>
             </a:pPr>
@@ -3539,17 +3539,17 @@
         <p:spPr>
           <a:xfrm>
             <a:off x="914400" y="4663440"/>
-            <a:ext cx="10362895" cy="1280160"/>
+            <a:ext cx="10362895" cy="1371600"/>
           </a:xfrm>
           <a:prstGeom prst="roundRect">
             <a:avLst/>
           </a:prstGeom>
           <a:solidFill>
-            <a:srgbClr val="0F172A"/>
+            <a:srgbClr val="0F1B30"/>
           </a:solidFill>
           <a:ln w="19050">
             <a:solidFill>
-              <a:srgbClr val="1F3A6E"/>
+              <a:srgbClr val="38BDF8"/>
             </a:solidFill>
           </a:ln>
         </p:spPr>
@@ -3584,7 +3584,7 @@
         <p:spPr>
           <a:xfrm>
             <a:off x="1097280" y="4754880"/>
-            <a:ext cx="9966960" cy="1051560"/>
+            <a:ext cx="9966960" cy="1143000"/>
           </a:xfrm>
           <a:prstGeom prst="rect">
             <a:avLst/>
@@ -3605,23 +3605,23 @@
               </a:defRPr>
             </a:pPr>
             <a:r>
-              <a:t>CORE ARCHITECTURAL SOVEREIGNTY &amp; DEPLOYMENT VERIFICATION</a:t>
+              <a:t>CORE SOVEREIGN SPECIFICATIONS &amp; VERIFIED REPOSITORY</a:t>
             </a:r>
           </a:p>
           <a:p>
             <a:pPr>
               <a:defRPr sz="900">
                 <a:solidFill>
-                  <a:srgbClr val="FFFFFF"/>
-                </a:solidFill>
-              </a:defRPr>
-            </a:pPr>
-            <a:r>
-              <a:t>• Resident Open-Weight LLMs: Qwen 2.5 Coder (7B) + Qwen 3 (8B) quantized via 4-bit memory management.</a:t>
+                  <a:srgbClr val="F1F5F9"/>
+                </a:solidFill>
+              </a:defRPr>
+            </a:pPr>
+            <a:r>
+              <a:t>• Resident Open-Weight LLMs: Qwen 2.5 Coder (7B) + Qwen 3 (8B) loaded in GPU memory with zero cloud egress.</a:t>
             </a:r>
             <a:br/>
             <a:r>
-              <a:t>• Deterministic Physics &amp; Codes: ASME B31.3 §304.1.2, Crane TP 410 (Darcy-Weisbach), ANSI/ISA-5.1, ISO 10816-3.</a:t>
+              <a:t>• Deterministic Engineering Solvers: ASME B31.3 §304.1.2 hoop stress, Crane TP 410 hydraulics, ISO 10816-3 vibration triage.</a:t>
             </a:r>
             <a:br/>
             <a:r>
@@ -3656,14 +3656,57 @@
         </p:nvSpPr>
         <p:spPr>
           <a:xfrm>
-            <a:off x="731520" y="365760"/>
-            <a:ext cx="10728655" cy="777240"/>
+            <a:off x="0" y="0"/>
+            <a:ext cx="12191695" cy="6858000"/>
           </a:xfrm>
           <a:prstGeom prst="rect">
             <a:avLst/>
           </a:prstGeom>
           <a:solidFill>
-            <a:srgbClr val="0A192F"/>
+            <a:srgbClr val="070F1E"/>
+          </a:solidFill>
+          <a:ln>
+            <a:noFill/>
+          </a:ln>
+        </p:spPr>
+        <p:style>
+          <a:lnRef idx="1">
+            <a:schemeClr val="accent1"/>
+          </a:lnRef>
+          <a:fillRef idx="3">
+            <a:schemeClr val="accent1"/>
+          </a:fillRef>
+          <a:effectRef idx="2">
+            <a:schemeClr val="accent1"/>
+          </a:effectRef>
+          <a:fontRef idx="minor">
+            <a:schemeClr val="lt1"/>
+          </a:fontRef>
+        </p:style>
+        <p:txBody>
+          <a:bodyPr rtlCol="0" anchor="ctr"/>
+          <a:lstStyle/>
+          <a:p>
+            <a:pPr algn="ctr"/>
+          </a:p>
+        </p:txBody>
+      </p:sp>
+      <p:sp>
+        <p:nvSpPr>
+          <p:cNvPr id="3" name="Rounded Rectangle 2"/>
+          <p:cNvSpPr/>
+          <p:nvPr/>
+        </p:nvSpPr>
+        <p:spPr>
+          <a:xfrm>
+            <a:off x="731520" y="320040"/>
+            <a:ext cx="10728655" cy="822960"/>
+          </a:xfrm>
+          <a:prstGeom prst="roundRect">
+            <a:avLst/>
+          </a:prstGeom>
+          <a:solidFill>
+            <a:srgbClr val="0F1B30"/>
           </a:solidFill>
           <a:ln w="19050">
             <a:solidFill>
@@ -3695,14 +3738,14 @@
       </p:sp>
       <p:sp>
         <p:nvSpPr>
-          <p:cNvPr id="3" name="TextBox 2"/>
+          <p:cNvPr id="4" name="TextBox 3"/>
           <p:cNvSpPr txBox="1"/>
           <p:nvPr/>
         </p:nvSpPr>
         <p:spPr>
           <a:xfrm>
-            <a:off x="914400" y="411480"/>
-            <a:ext cx="7772400" cy="685800"/>
+            <a:off x="914400" y="384048"/>
+            <a:ext cx="7772400" cy="713232"/>
           </a:xfrm>
           <a:prstGeom prst="rect">
             <a:avLst/>
@@ -3710,7 +3753,7 @@
           <a:noFill/>
         </p:spPr>
         <p:txBody>
-          <a:bodyPr wrap="none" lIns="0" tIns="0" rIns="0" bIns="0">
+          <a:bodyPr wrap="square" lIns="0" tIns="0" rIns="0" bIns="0">
             <a:spAutoFit/>
           </a:bodyPr>
           <a:lstStyle/>
@@ -3737,31 +3780,31 @@
               </a:defRPr>
             </a:pPr>
             <a:r>
-              <a:t>Direct Architectural Moat vs Cloud LLMs &amp; Generic Local Wrappers</a:t>
-            </a:r>
-          </a:p>
-        </p:txBody>
-      </p:sp>
-      <p:sp>
-        <p:nvSpPr>
-          <p:cNvPr id="4" name="Rounded Rectangle 3"/>
+              <a:t>Architectural Moat vs Cloud LLMs &amp; Generic Local Wrappers</a:t>
+            </a:r>
+          </a:p>
+        </p:txBody>
+      </p:sp>
+      <p:sp>
+        <p:nvSpPr>
+          <p:cNvPr id="5" name="Rounded Rectangle 4"/>
           <p:cNvSpPr/>
           <p:nvPr/>
         </p:nvSpPr>
         <p:spPr>
           <a:xfrm>
-            <a:off x="8961120" y="502920"/>
-            <a:ext cx="2286000" cy="457200"/>
+            <a:off x="8961120" y="475488"/>
+            <a:ext cx="2286000" cy="475488"/>
           </a:xfrm>
           <a:prstGeom prst="roundRect">
             <a:avLst/>
           </a:prstGeom>
           <a:solidFill>
-            <a:srgbClr val="1F3A6E"/>
+            <a:srgbClr val="172541"/>
           </a:solidFill>
-          <a:ln>
+          <a:ln w="15875">
             <a:solidFill>
-              <a:srgbClr val="38BDF8"/>
+              <a:srgbClr val="F59E0B"/>
             </a:solidFill>
           </a:ln>
         </p:spPr>
@@ -3786,7 +3829,7 @@
             <a:pPr algn="ctr">
               <a:defRPr b="1" sz="900">
                 <a:solidFill>
-                  <a:srgbClr val="FFFFFF"/>
+                  <a:srgbClr val="F59E0B"/>
                 </a:solidFill>
               </a:defRPr>
             </a:pPr>
@@ -3798,7 +3841,7 @@
       </p:sp>
       <p:sp>
         <p:nvSpPr>
-          <p:cNvPr id="5" name="Rectangle 4"/>
+          <p:cNvPr id="6" name="Rectangle 5"/>
           <p:cNvSpPr/>
           <p:nvPr/>
         </p:nvSpPr>
@@ -3811,7 +3854,7 @@
             <a:avLst/>
           </a:prstGeom>
           <a:solidFill>
-            <a:srgbClr val="E2E8F0"/>
+            <a:srgbClr val="1E3A66"/>
           </a:solidFill>
           <a:ln>
             <a:noFill/>
@@ -3841,7 +3884,7 @@
       </p:sp>
       <p:sp>
         <p:nvSpPr>
-          <p:cNvPr id="6" name="TextBox 5"/>
+          <p:cNvPr id="7" name="TextBox 6"/>
           <p:cNvSpPr txBox="1"/>
           <p:nvPr/>
         </p:nvSpPr>
@@ -3864,20 +3907,20 @@
             <a:pPr>
               <a:defRPr sz="800">
                 <a:solidFill>
-                  <a:srgbClr val="64748B"/>
+                  <a:srgbClr val="94A3B8"/>
                 </a:solidFill>
                 <a:latin typeface="Calibri"/>
               </a:defRPr>
             </a:pPr>
             <a:r>
-              <a:t>INDRA SOVEREIGN ENGINEERING WORKBENCH • AIR-GAP ZERO-WAN AUDITED • SM-26117 • SLIDE 2 OF 6</a:t>
+              <a:t>INDRA SOVEREIGN WORKBENCH • AIR-GAP ZERO-WAN AUDITED • SM-26117 • SLIDE 2 OF 6</a:t>
             </a:r>
           </a:p>
         </p:txBody>
       </p:sp>
       <p:graphicFrame>
         <p:nvGraphicFramePr>
-          <p:cNvPr id="7" name="Table 6"/>
+          <p:cNvPr id="8" name="Table 7"/>
           <p:cNvGraphicFramePr>
             <a:graphicFrameLocks noGrp="1"/>
           </p:cNvGraphicFramePr>
@@ -3885,7 +3928,7 @@
         </p:nvGraphicFramePr>
         <p:xfrm>
           <a:off x="731520" y="1325880"/>
-          <a:ext cx="6858000" cy="4754880"/>
+          <a:ext cx="6949440" cy="4754880"/>
         </p:xfrm>
         <a:graphic>
           <a:graphicData uri="http://schemas.openxmlformats.org/drawingml/2006/table">
@@ -3897,7 +3940,7 @@
                 <a:gridCol w="1920240"/>
                 <a:gridCol w="1554480"/>
                 <a:gridCol w="1554480"/>
-                <a:gridCol w="1828800"/>
+                <a:gridCol w="1920240"/>
               </a:tblGrid>
               <a:tr h="792480">
                 <a:tc>
@@ -3908,7 +3951,7 @@
                       <a:pPr>
                         <a:defRPr b="1" sz="900">
                           <a:solidFill>
-                            <a:srgbClr val="FFFFFF"/>
+                            <a:srgbClr val="38BDF8"/>
                           </a:solidFill>
                         </a:defRPr>
                       </a:pPr>
@@ -3919,7 +3962,7 @@
                   </a:txBody>
                   <a:tcPr>
                     <a:solidFill>
-                      <a:srgbClr val="1F3A6E"/>
+                      <a:srgbClr val="172541"/>
                     </a:solidFill>
                   </a:tcPr>
                 </a:tc>
@@ -3931,7 +3974,7 @@
                       <a:pPr>
                         <a:defRPr b="1" sz="900">
                           <a:solidFill>
-                            <a:srgbClr val="FFFFFF"/>
+                            <a:srgbClr val="38BDF8"/>
                           </a:solidFill>
                         </a:defRPr>
                       </a:pPr>
@@ -3942,7 +3985,7 @@
                   </a:txBody>
                   <a:tcPr>
                     <a:solidFill>
-                      <a:srgbClr val="1F3A6E"/>
+                      <a:srgbClr val="172541"/>
                     </a:solidFill>
                   </a:tcPr>
                 </a:tc>
@@ -3954,7 +3997,7 @@
                       <a:pPr>
                         <a:defRPr b="1" sz="900">
                           <a:solidFill>
-                            <a:srgbClr val="FFFFFF"/>
+                            <a:srgbClr val="38BDF8"/>
                           </a:solidFill>
                         </a:defRPr>
                       </a:pPr>
@@ -3965,7 +4008,7 @@
                   </a:txBody>
                   <a:tcPr>
                     <a:solidFill>
-                      <a:srgbClr val="1F3A6E"/>
+                      <a:srgbClr val="172541"/>
                     </a:solidFill>
                   </a:tcPr>
                 </a:tc>
@@ -3977,7 +4020,7 @@
                       <a:pPr>
                         <a:defRPr b="1" sz="900">
                           <a:solidFill>
-                            <a:srgbClr val="FFFFFF"/>
+                            <a:srgbClr val="38BDF8"/>
                           </a:solidFill>
                         </a:defRPr>
                       </a:pPr>
@@ -3988,7 +4031,7 @@
                   </a:txBody>
                   <a:tcPr>
                     <a:solidFill>
-                      <a:srgbClr val="1F3A6E"/>
+                      <a:srgbClr val="172541"/>
                     </a:solidFill>
                   </a:tcPr>
                 </a:tc>
@@ -4002,7 +4045,7 @@
                       <a:pPr>
                         <a:defRPr sz="850">
                           <a:solidFill>
-                            <a:srgbClr val="0F172A"/>
+                            <a:srgbClr val="94A3B8"/>
                           </a:solidFill>
                         </a:defRPr>
                       </a:pPr>
@@ -4013,7 +4056,7 @@
                   </a:txBody>
                   <a:tcPr>
                     <a:solidFill>
-                      <a:srgbClr val="FFFFFF"/>
+                      <a:srgbClr val="0F1B30"/>
                     </a:solidFill>
                   </a:tcPr>
                 </a:tc>
@@ -4025,7 +4068,7 @@
                       <a:pPr>
                         <a:defRPr sz="850">
                           <a:solidFill>
-                            <a:srgbClr val="0F172A"/>
+                            <a:srgbClr val="94A3B8"/>
                           </a:solidFill>
                         </a:defRPr>
                       </a:pPr>
@@ -4036,7 +4079,7 @@
                   </a:txBody>
                   <a:tcPr>
                     <a:solidFill>
-                      <a:srgbClr val="FFFFFF"/>
+                      <a:srgbClr val="0F1B30"/>
                     </a:solidFill>
                   </a:tcPr>
                 </a:tc>
@@ -4048,7 +4091,7 @@
                       <a:pPr>
                         <a:defRPr sz="850">
                           <a:solidFill>
-                            <a:srgbClr val="0F172A"/>
+                            <a:srgbClr val="94A3B8"/>
                           </a:solidFill>
                         </a:defRPr>
                       </a:pPr>
@@ -4059,7 +4102,7 @@
                   </a:txBody>
                   <a:tcPr>
                     <a:solidFill>
-                      <a:srgbClr val="FFFFFF"/>
+                      <a:srgbClr val="0F1B30"/>
                     </a:solidFill>
                   </a:tcPr>
                 </a:tc>
@@ -4071,7 +4114,7 @@
                       <a:pPr>
                         <a:defRPr sz="850" b="1">
                           <a:solidFill>
-                            <a:srgbClr val="059669"/>
+                            <a:srgbClr val="10B981"/>
                           </a:solidFill>
                         </a:defRPr>
                       </a:pPr>
@@ -4082,7 +4125,7 @@
                   </a:txBody>
                   <a:tcPr>
                     <a:solidFill>
-                      <a:srgbClr val="FFFFFF"/>
+                      <a:srgbClr val="0F1B30"/>
                     </a:solidFill>
                   </a:tcPr>
                 </a:tc>
@@ -4096,7 +4139,7 @@
                       <a:pPr>
                         <a:defRPr sz="850">
                           <a:solidFill>
-                            <a:srgbClr val="0F172A"/>
+                            <a:srgbClr val="94A3B8"/>
                           </a:solidFill>
                         </a:defRPr>
                       </a:pPr>
@@ -4107,7 +4150,7 @@
                   </a:txBody>
                   <a:tcPr>
                     <a:solidFill>
-                      <a:srgbClr val="F1F5F9"/>
+                      <a:srgbClr val="0C1628"/>
                     </a:solidFill>
                   </a:tcPr>
                 </a:tc>
@@ -4119,7 +4162,7 @@
                       <a:pPr>
                         <a:defRPr sz="850">
                           <a:solidFill>
-                            <a:srgbClr val="0F172A"/>
+                            <a:srgbClr val="94A3B8"/>
                           </a:solidFill>
                         </a:defRPr>
                       </a:pPr>
@@ -4130,7 +4173,7 @@
                   </a:txBody>
                   <a:tcPr>
                     <a:solidFill>
-                      <a:srgbClr val="F1F5F9"/>
+                      <a:srgbClr val="0C1628"/>
                     </a:solidFill>
                   </a:tcPr>
                 </a:tc>
@@ -4142,7 +4185,7 @@
                       <a:pPr>
                         <a:defRPr sz="850">
                           <a:solidFill>
-                            <a:srgbClr val="0F172A"/>
+                            <a:srgbClr val="94A3B8"/>
                           </a:solidFill>
                         </a:defRPr>
                       </a:pPr>
@@ -4153,7 +4196,7 @@
                   </a:txBody>
                   <a:tcPr>
                     <a:solidFill>
-                      <a:srgbClr val="F1F5F9"/>
+                      <a:srgbClr val="0C1628"/>
                     </a:solidFill>
                   </a:tcPr>
                 </a:tc>
@@ -4165,7 +4208,7 @@
                       <a:pPr>
                         <a:defRPr sz="850" b="1">
                           <a:solidFill>
-                            <a:srgbClr val="059669"/>
+                            <a:srgbClr val="10B981"/>
                           </a:solidFill>
                         </a:defRPr>
                       </a:pPr>
@@ -4176,7 +4219,7 @@
                   </a:txBody>
                   <a:tcPr>
                     <a:solidFill>
-                      <a:srgbClr val="F1F5F9"/>
+                      <a:srgbClr val="0C1628"/>
                     </a:solidFill>
                   </a:tcPr>
                 </a:tc>
@@ -4190,7 +4233,7 @@
                       <a:pPr>
                         <a:defRPr sz="850">
                           <a:solidFill>
-                            <a:srgbClr val="0F172A"/>
+                            <a:srgbClr val="94A3B8"/>
                           </a:solidFill>
                         </a:defRPr>
                       </a:pPr>
@@ -4201,7 +4244,7 @@
                   </a:txBody>
                   <a:tcPr>
                     <a:solidFill>
-                      <a:srgbClr val="FFFFFF"/>
+                      <a:srgbClr val="0F1B30"/>
                     </a:solidFill>
                   </a:tcPr>
                 </a:tc>
@@ -4213,7 +4256,7 @@
                       <a:pPr>
                         <a:defRPr sz="850">
                           <a:solidFill>
-                            <a:srgbClr val="0F172A"/>
+                            <a:srgbClr val="94A3B8"/>
                           </a:solidFill>
                         </a:defRPr>
                       </a:pPr>
@@ -4224,7 +4267,7 @@
                   </a:txBody>
                   <a:tcPr>
                     <a:solidFill>
-                      <a:srgbClr val="FFFFFF"/>
+                      <a:srgbClr val="0F1B30"/>
                     </a:solidFill>
                   </a:tcPr>
                 </a:tc>
@@ -4236,7 +4279,7 @@
                       <a:pPr>
                         <a:defRPr sz="850">
                           <a:solidFill>
-                            <a:srgbClr val="0F172A"/>
+                            <a:srgbClr val="94A3B8"/>
                           </a:solidFill>
                         </a:defRPr>
                       </a:pPr>
@@ -4247,7 +4290,7 @@
                   </a:txBody>
                   <a:tcPr>
                     <a:solidFill>
-                      <a:srgbClr val="FFFFFF"/>
+                      <a:srgbClr val="0F1B30"/>
                     </a:solidFill>
                   </a:tcPr>
                 </a:tc>
@@ -4259,7 +4302,7 @@
                       <a:pPr>
                         <a:defRPr sz="850" b="1">
                           <a:solidFill>
-                            <a:srgbClr val="059669"/>
+                            <a:srgbClr val="10B981"/>
                           </a:solidFill>
                         </a:defRPr>
                       </a:pPr>
@@ -4270,7 +4313,7 @@
                   </a:txBody>
                   <a:tcPr>
                     <a:solidFill>
-                      <a:srgbClr val="FFFFFF"/>
+                      <a:srgbClr val="0F1B30"/>
                     </a:solidFill>
                   </a:tcPr>
                 </a:tc>
@@ -4284,7 +4327,7 @@
                       <a:pPr>
                         <a:defRPr sz="850">
                           <a:solidFill>
-                            <a:srgbClr val="0F172A"/>
+                            <a:srgbClr val="94A3B8"/>
                           </a:solidFill>
                         </a:defRPr>
                       </a:pPr>
@@ -4295,7 +4338,7 @@
                   </a:txBody>
                   <a:tcPr>
                     <a:solidFill>
-                      <a:srgbClr val="F1F5F9"/>
+                      <a:srgbClr val="0C1628"/>
                     </a:solidFill>
                   </a:tcPr>
                 </a:tc>
@@ -4307,7 +4350,7 @@
                       <a:pPr>
                         <a:defRPr sz="850">
                           <a:solidFill>
-                            <a:srgbClr val="0F172A"/>
+                            <a:srgbClr val="94A3B8"/>
                           </a:solidFill>
                         </a:defRPr>
                       </a:pPr>
@@ -4318,7 +4361,7 @@
                   </a:txBody>
                   <a:tcPr>
                     <a:solidFill>
-                      <a:srgbClr val="F1F5F9"/>
+                      <a:srgbClr val="0C1628"/>
                     </a:solidFill>
                   </a:tcPr>
                 </a:tc>
@@ -4330,7 +4373,7 @@
                       <a:pPr>
                         <a:defRPr sz="850">
                           <a:solidFill>
-                            <a:srgbClr val="0F172A"/>
+                            <a:srgbClr val="94A3B8"/>
                           </a:solidFill>
                         </a:defRPr>
                       </a:pPr>
@@ -4341,7 +4384,7 @@
                   </a:txBody>
                   <a:tcPr>
                     <a:solidFill>
-                      <a:srgbClr val="F1F5F9"/>
+                      <a:srgbClr val="0C1628"/>
                     </a:solidFill>
                   </a:tcPr>
                 </a:tc>
@@ -4353,7 +4396,7 @@
                       <a:pPr>
                         <a:defRPr sz="850" b="1">
                           <a:solidFill>
-                            <a:srgbClr val="059669"/>
+                            <a:srgbClr val="10B981"/>
                           </a:solidFill>
                         </a:defRPr>
                       </a:pPr>
@@ -4364,7 +4407,7 @@
                   </a:txBody>
                   <a:tcPr>
                     <a:solidFill>
-                      <a:srgbClr val="F1F5F9"/>
+                      <a:srgbClr val="0C1628"/>
                     </a:solidFill>
                   </a:tcPr>
                 </a:tc>
@@ -4378,7 +4421,7 @@
                       <a:pPr>
                         <a:defRPr sz="850">
                           <a:solidFill>
-                            <a:srgbClr val="0F172A"/>
+                            <a:srgbClr val="94A3B8"/>
                           </a:solidFill>
                         </a:defRPr>
                       </a:pPr>
@@ -4389,7 +4432,7 @@
                   </a:txBody>
                   <a:tcPr>
                     <a:solidFill>
-                      <a:srgbClr val="FFFFFF"/>
+                      <a:srgbClr val="0F1B30"/>
                     </a:solidFill>
                   </a:tcPr>
                 </a:tc>
@@ -4401,7 +4444,7 @@
                       <a:pPr>
                         <a:defRPr sz="850">
                           <a:solidFill>
-                            <a:srgbClr val="0F172A"/>
+                            <a:srgbClr val="94A3B8"/>
                           </a:solidFill>
                         </a:defRPr>
                       </a:pPr>
@@ -4412,7 +4455,7 @@
                   </a:txBody>
                   <a:tcPr>
                     <a:solidFill>
-                      <a:srgbClr val="FFFFFF"/>
+                      <a:srgbClr val="0F1B30"/>
                     </a:solidFill>
                   </a:tcPr>
                 </a:tc>
@@ -4424,7 +4467,7 @@
                       <a:pPr>
                         <a:defRPr sz="850">
                           <a:solidFill>
-                            <a:srgbClr val="0F172A"/>
+                            <a:srgbClr val="94A3B8"/>
                           </a:solidFill>
                         </a:defRPr>
                       </a:pPr>
@@ -4435,7 +4478,7 @@
                   </a:txBody>
                   <a:tcPr>
                     <a:solidFill>
-                      <a:srgbClr val="FFFFFF"/>
+                      <a:srgbClr val="0F1B30"/>
                     </a:solidFill>
                   </a:tcPr>
                 </a:tc>
@@ -4447,7 +4490,7 @@
                       <a:pPr>
                         <a:defRPr sz="850" b="1">
                           <a:solidFill>
-                            <a:srgbClr val="059669"/>
+                            <a:srgbClr val="10B981"/>
                           </a:solidFill>
                         </a:defRPr>
                       </a:pPr>
@@ -4458,7 +4501,7 @@
                   </a:txBody>
                   <a:tcPr>
                     <a:solidFill>
-                      <a:srgbClr val="FFFFFF"/>
+                      <a:srgbClr val="0F1B30"/>
                     </a:solidFill>
                   </a:tcPr>
                 </a:tc>
@@ -4469,24 +4512,24 @@
       </p:graphicFrame>
       <p:sp>
         <p:nvSpPr>
-          <p:cNvPr id="8" name="Rounded Rectangle 7"/>
+          <p:cNvPr id="9" name="Rounded Rectangle 8"/>
           <p:cNvSpPr/>
           <p:nvPr/>
         </p:nvSpPr>
         <p:spPr>
           <a:xfrm>
-            <a:off x="7772400" y="1325880"/>
-            <a:ext cx="3657600" cy="1463040"/>
+            <a:off x="7863840" y="1325880"/>
+            <a:ext cx="3566160" cy="1463040"/>
           </a:xfrm>
           <a:prstGeom prst="roundRect">
             <a:avLst/>
           </a:prstGeom>
           <a:solidFill>
-            <a:srgbClr val="F8FAFC"/>
+            <a:srgbClr val="172541"/>
           </a:solidFill>
-          <a:ln w="22225">
+          <a:ln w="19050">
             <a:solidFill>
-              <a:srgbClr val="059669"/>
+              <a:srgbClr val="10B981"/>
             </a:solidFill>
           </a:ln>
         </p:spPr>
@@ -4514,14 +4557,14 @@
       </p:sp>
       <p:sp>
         <p:nvSpPr>
-          <p:cNvPr id="9" name="TextBox 8"/>
+          <p:cNvPr id="10" name="TextBox 9"/>
           <p:cNvSpPr txBox="1"/>
           <p:nvPr/>
         </p:nvSpPr>
         <p:spPr>
           <a:xfrm>
-            <a:off x="7909560" y="1435607"/>
-            <a:ext cx="3383280" cy="1243584"/>
+            <a:off x="8001000" y="1435607"/>
+            <a:ext cx="3291840" cy="1243584"/>
           </a:xfrm>
           <a:prstGeom prst="rect">
             <a:avLst/>
@@ -4537,7 +4580,7 @@
             <a:pPr>
               <a:defRPr b="1" sz="900">
                 <a:solidFill>
-                  <a:srgbClr val="64748B"/>
+                  <a:srgbClr val="10B981"/>
                 </a:solidFill>
               </a:defRPr>
             </a:pPr>
@@ -4547,9 +4590,9 @@
           </a:p>
           <a:p>
             <a:pPr>
-              <a:defRPr b="1" sz="1800">
-                <a:solidFill>
-                  <a:srgbClr val="059669"/>
+              <a:defRPr b="1" sz="1700">
+                <a:solidFill>
+                  <a:srgbClr val="FFFFFF"/>
                 </a:solidFill>
               </a:defRPr>
             </a:pPr>
@@ -4561,7 +4604,7 @@
             <a:pPr>
               <a:defRPr sz="850">
                 <a:solidFill>
-                  <a:srgbClr val="0F172A"/>
+                  <a:srgbClr val="94A3B8"/>
                 </a:solidFill>
               </a:defRPr>
             </a:pPr>
@@ -4573,24 +4616,24 @@
       </p:sp>
       <p:sp>
         <p:nvSpPr>
-          <p:cNvPr id="10" name="Rounded Rectangle 9"/>
+          <p:cNvPr id="11" name="Rounded Rectangle 10"/>
           <p:cNvSpPr/>
           <p:nvPr/>
         </p:nvSpPr>
         <p:spPr>
           <a:xfrm>
-            <a:off x="7772400" y="2926080"/>
-            <a:ext cx="3657600" cy="1463040"/>
+            <a:off x="7863840" y="2926080"/>
+            <a:ext cx="3566160" cy="1463040"/>
           </a:xfrm>
           <a:prstGeom prst="roundRect">
             <a:avLst/>
           </a:prstGeom>
           <a:solidFill>
-            <a:srgbClr val="F8FAFC"/>
+            <a:srgbClr val="172541"/>
           </a:solidFill>
-          <a:ln w="22225">
+          <a:ln w="19050">
             <a:solidFill>
-              <a:srgbClr val="1F3A6E"/>
+              <a:srgbClr val="38BDF8"/>
             </a:solidFill>
           </a:ln>
         </p:spPr>
@@ -4618,14 +4661,14 @@
       </p:sp>
       <p:sp>
         <p:nvSpPr>
-          <p:cNvPr id="11" name="TextBox 10"/>
+          <p:cNvPr id="12" name="TextBox 11"/>
           <p:cNvSpPr txBox="1"/>
           <p:nvPr/>
         </p:nvSpPr>
         <p:spPr>
           <a:xfrm>
-            <a:off x="7909560" y="3035808"/>
-            <a:ext cx="3383280" cy="1243584"/>
+            <a:off x="8001000" y="3035808"/>
+            <a:ext cx="3291840" cy="1243584"/>
           </a:xfrm>
           <a:prstGeom prst="rect">
             <a:avLst/>
@@ -4641,7 +4684,7 @@
             <a:pPr>
               <a:defRPr b="1" sz="900">
                 <a:solidFill>
-                  <a:srgbClr val="64748B"/>
+                  <a:srgbClr val="38BDF8"/>
                 </a:solidFill>
               </a:defRPr>
             </a:pPr>
@@ -4651,9 +4694,9 @@
           </a:p>
           <a:p>
             <a:pPr>
-              <a:defRPr b="1" sz="1800">
-                <a:solidFill>
-                  <a:srgbClr val="1F3A6E"/>
+              <a:defRPr b="1" sz="1700">
+                <a:solidFill>
+                  <a:srgbClr val="FFFFFF"/>
                 </a:solidFill>
               </a:defRPr>
             </a:pPr>
@@ -4665,36 +4708,36 @@
             <a:pPr>
               <a:defRPr sz="850">
                 <a:solidFill>
-                  <a:srgbClr val="0F172A"/>
-                </a:solidFill>
-              </a:defRPr>
-            </a:pPr>
-            <a:r>
-              <a:t>Eliminates hours of manual reporting by auto-compiling formal Word statutory approval notes, Excel engineering workbooks, and board decks.</a:t>
-            </a:r>
-          </a:p>
-        </p:txBody>
-      </p:sp>
-      <p:sp>
-        <p:nvSpPr>
-          <p:cNvPr id="12" name="Rounded Rectangle 11"/>
+                  <a:srgbClr val="94A3B8"/>
+                </a:solidFill>
+              </a:defRPr>
+            </a:pPr>
+            <a:r>
+              <a:t>Auto-compiles formal Word statutory notes, Excel engineering calculation sheets, and 16:9 executive presentation decks in &lt;3.5 seconds.</a:t>
+            </a:r>
+          </a:p>
+        </p:txBody>
+      </p:sp>
+      <p:sp>
+        <p:nvSpPr>
+          <p:cNvPr id="13" name="Rounded Rectangle 12"/>
           <p:cNvSpPr/>
           <p:nvPr/>
         </p:nvSpPr>
         <p:spPr>
           <a:xfrm>
-            <a:off x="7772400" y="4526280"/>
-            <a:ext cx="3657600" cy="1463040"/>
+            <a:off x="7863840" y="4526280"/>
+            <a:ext cx="3566160" cy="1463040"/>
           </a:xfrm>
           <a:prstGeom prst="roundRect">
             <a:avLst/>
           </a:prstGeom>
           <a:solidFill>
-            <a:srgbClr val="F8FAFC"/>
+            <a:srgbClr val="172541"/>
           </a:solidFill>
-          <a:ln w="22225">
+          <a:ln w="19050">
             <a:solidFill>
-              <a:srgbClr val="D97706"/>
+              <a:srgbClr val="F59E0B"/>
             </a:solidFill>
           </a:ln>
         </p:spPr>
@@ -4722,14 +4765,14 @@
       </p:sp>
       <p:sp>
         <p:nvSpPr>
-          <p:cNvPr id="13" name="TextBox 12"/>
+          <p:cNvPr id="14" name="TextBox 13"/>
           <p:cNvSpPr txBox="1"/>
           <p:nvPr/>
         </p:nvSpPr>
         <p:spPr>
           <a:xfrm>
-            <a:off x="7909560" y="4636008"/>
-            <a:ext cx="3383280" cy="1243584"/>
+            <a:off x="8001000" y="4636008"/>
+            <a:ext cx="3291840" cy="1243584"/>
           </a:xfrm>
           <a:prstGeom prst="rect">
             <a:avLst/>
@@ -4745,7 +4788,7 @@
             <a:pPr>
               <a:defRPr b="1" sz="900">
                 <a:solidFill>
-                  <a:srgbClr val="64748B"/>
+                  <a:srgbClr val="F59E0B"/>
                 </a:solidFill>
               </a:defRPr>
             </a:pPr>
@@ -4755,9 +4798,9 @@
           </a:p>
           <a:p>
             <a:pPr>
-              <a:defRPr b="1" sz="1800">
-                <a:solidFill>
-                  <a:srgbClr val="D97706"/>
+              <a:defRPr b="1" sz="1700">
+                <a:solidFill>
+                  <a:srgbClr val="FFFFFF"/>
                 </a:solidFill>
               </a:defRPr>
             </a:pPr>
@@ -4769,7 +4812,7 @@
             <a:pPr>
               <a:defRPr sz="850">
                 <a:solidFill>
-                  <a:srgbClr val="0F172A"/>
+                  <a:srgbClr val="94A3B8"/>
                 </a:solidFill>
               </a:defRPr>
             </a:pPr>
@@ -4805,14 +4848,57 @@
         </p:nvSpPr>
         <p:spPr>
           <a:xfrm>
-            <a:off x="731520" y="365760"/>
-            <a:ext cx="10728655" cy="777240"/>
+            <a:off x="0" y="0"/>
+            <a:ext cx="12191695" cy="6858000"/>
           </a:xfrm>
           <a:prstGeom prst="rect">
             <a:avLst/>
           </a:prstGeom>
           <a:solidFill>
-            <a:srgbClr val="0A192F"/>
+            <a:srgbClr val="070F1E"/>
+          </a:solidFill>
+          <a:ln>
+            <a:noFill/>
+          </a:ln>
+        </p:spPr>
+        <p:style>
+          <a:lnRef idx="1">
+            <a:schemeClr val="accent1"/>
+          </a:lnRef>
+          <a:fillRef idx="3">
+            <a:schemeClr val="accent1"/>
+          </a:fillRef>
+          <a:effectRef idx="2">
+            <a:schemeClr val="accent1"/>
+          </a:effectRef>
+          <a:fontRef idx="minor">
+            <a:schemeClr val="lt1"/>
+          </a:fontRef>
+        </p:style>
+        <p:txBody>
+          <a:bodyPr rtlCol="0" anchor="ctr"/>
+          <a:lstStyle/>
+          <a:p>
+            <a:pPr algn="ctr"/>
+          </a:p>
+        </p:txBody>
+      </p:sp>
+      <p:sp>
+        <p:nvSpPr>
+          <p:cNvPr id="3" name="Rounded Rectangle 2"/>
+          <p:cNvSpPr/>
+          <p:nvPr/>
+        </p:nvSpPr>
+        <p:spPr>
+          <a:xfrm>
+            <a:off x="731520" y="320040"/>
+            <a:ext cx="10728655" cy="822960"/>
+          </a:xfrm>
+          <a:prstGeom prst="roundRect">
+            <a:avLst/>
+          </a:prstGeom>
+          <a:solidFill>
+            <a:srgbClr val="0F1B30"/>
           </a:solidFill>
           <a:ln w="19050">
             <a:solidFill>
@@ -4844,14 +4930,14 @@
       </p:sp>
       <p:sp>
         <p:nvSpPr>
-          <p:cNvPr id="3" name="TextBox 2"/>
+          <p:cNvPr id="4" name="TextBox 3"/>
           <p:cNvSpPr txBox="1"/>
           <p:nvPr/>
         </p:nvSpPr>
         <p:spPr>
           <a:xfrm>
-            <a:off x="914400" y="411480"/>
-            <a:ext cx="7772400" cy="685800"/>
+            <a:off x="914400" y="384048"/>
+            <a:ext cx="7772400" cy="713232"/>
           </a:xfrm>
           <a:prstGeom prst="rect">
             <a:avLst/>
@@ -4859,7 +4945,7 @@
           <a:noFill/>
         </p:spPr>
         <p:txBody>
-          <a:bodyPr wrap="none" lIns="0" tIns="0" rIns="0" bIns="0">
+          <a:bodyPr wrap="square" lIns="0" tIns="0" rIns="0" bIns="0">
             <a:spAutoFit/>
           </a:bodyPr>
           <a:lstStyle/>
@@ -4893,24 +4979,24 @@
       </p:sp>
       <p:sp>
         <p:nvSpPr>
-          <p:cNvPr id="4" name="Rounded Rectangle 3"/>
+          <p:cNvPr id="5" name="Rounded Rectangle 4"/>
           <p:cNvSpPr/>
           <p:nvPr/>
         </p:nvSpPr>
         <p:spPr>
           <a:xfrm>
-            <a:off x="8961120" y="502920"/>
-            <a:ext cx="2286000" cy="457200"/>
+            <a:off x="8961120" y="475488"/>
+            <a:ext cx="2286000" cy="475488"/>
           </a:xfrm>
           <a:prstGeom prst="roundRect">
             <a:avLst/>
           </a:prstGeom>
           <a:solidFill>
-            <a:srgbClr val="1F3A6E"/>
+            <a:srgbClr val="172541"/>
           </a:solidFill>
-          <a:ln>
+          <a:ln w="15875">
             <a:solidFill>
-              <a:srgbClr val="38BDF8"/>
+              <a:srgbClr val="F59E0B"/>
             </a:solidFill>
           </a:ln>
         </p:spPr>
@@ -4935,7 +5021,7 @@
             <a:pPr algn="ctr">
               <a:defRPr b="1" sz="900">
                 <a:solidFill>
-                  <a:srgbClr val="FFFFFF"/>
+                  <a:srgbClr val="F59E0B"/>
                 </a:solidFill>
               </a:defRPr>
             </a:pPr>
@@ -4947,7 +5033,7 @@
       </p:sp>
       <p:sp>
         <p:nvSpPr>
-          <p:cNvPr id="5" name="Rectangle 4"/>
+          <p:cNvPr id="6" name="Rectangle 5"/>
           <p:cNvSpPr/>
           <p:nvPr/>
         </p:nvSpPr>
@@ -4960,7 +5046,7 @@
             <a:avLst/>
           </a:prstGeom>
           <a:solidFill>
-            <a:srgbClr val="E2E8F0"/>
+            <a:srgbClr val="1E3A66"/>
           </a:solidFill>
           <a:ln>
             <a:noFill/>
@@ -4990,7 +5076,7 @@
       </p:sp>
       <p:sp>
         <p:nvSpPr>
-          <p:cNvPr id="6" name="TextBox 5"/>
+          <p:cNvPr id="7" name="TextBox 6"/>
           <p:cNvSpPr txBox="1"/>
           <p:nvPr/>
         </p:nvSpPr>
@@ -5013,20 +5099,20 @@
             <a:pPr>
               <a:defRPr sz="800">
                 <a:solidFill>
-                  <a:srgbClr val="64748B"/>
+                  <a:srgbClr val="94A3B8"/>
                 </a:solidFill>
                 <a:latin typeface="Calibri"/>
               </a:defRPr>
             </a:pPr>
             <a:r>
-              <a:t>INDRA SOVEREIGN ENGINEERING WORKBENCH • AIR-GAP ZERO-WAN AUDITED • SM-26117 • SLIDE 3 OF 6</a:t>
-            </a:r>
-          </a:p>
-        </p:txBody>
-      </p:sp>
-      <p:sp>
-        <p:nvSpPr>
-          <p:cNvPr id="7" name="Rounded Rectangle 6"/>
+              <a:t>INDRA SOVEREIGN WORKBENCH • AIR-GAP ZERO-WAN AUDITED • SM-26117 • SLIDE 3 OF 6</a:t>
+            </a:r>
+          </a:p>
+        </p:txBody>
+      </p:sp>
+      <p:sp>
+        <p:nvSpPr>
+          <p:cNvPr id="8" name="Rounded Rectangle 7"/>
           <p:cNvSpPr/>
           <p:nvPr/>
         </p:nvSpPr>
@@ -5039,7 +5125,7 @@
             <a:avLst/>
           </a:prstGeom>
           <a:solidFill>
-            <a:srgbClr val="F8FAFC"/>
+            <a:srgbClr val="172541"/>
           </a:solidFill>
           <a:ln w="22225">
             <a:solidFill>
@@ -5071,7 +5157,7 @@
       </p:sp>
       <p:sp>
         <p:nvSpPr>
-          <p:cNvPr id="8" name="TextBox 7"/>
+          <p:cNvPr id="9" name="TextBox 8"/>
           <p:cNvSpPr txBox="1"/>
           <p:nvPr/>
         </p:nvSpPr>
@@ -5106,7 +5192,7 @@
             <a:pPr>
               <a:defRPr b="1" sz="1100">
                 <a:solidFill>
-                  <a:srgbClr val="0A192F"/>
+                  <a:srgbClr val="FFFFFF"/>
                 </a:solidFill>
               </a:defRPr>
             </a:pPr>
@@ -5118,7 +5204,7 @@
             <a:pPr>
               <a:defRPr sz="850">
                 <a:solidFill>
-                  <a:srgbClr val="0F172A"/>
+                  <a:srgbClr val="94A3B8"/>
                 </a:solidFill>
               </a:defRPr>
             </a:pPr>
@@ -5138,7 +5224,7 @@
       </p:sp>
       <p:sp>
         <p:nvSpPr>
-          <p:cNvPr id="9" name="Rounded Rectangle 8"/>
+          <p:cNvPr id="10" name="Rounded Rectangle 9"/>
           <p:cNvSpPr/>
           <p:nvPr/>
         </p:nvSpPr>
@@ -5151,11 +5237,11 @@
             <a:avLst/>
           </a:prstGeom>
           <a:solidFill>
-            <a:srgbClr val="F8FAFC"/>
+            <a:srgbClr val="172541"/>
           </a:solidFill>
           <a:ln w="22225">
             <a:solidFill>
-              <a:srgbClr val="1F3A6E"/>
+              <a:srgbClr val="A855F7"/>
             </a:solidFill>
           </a:ln>
         </p:spPr>
@@ -5183,7 +5269,7 @@
       </p:sp>
       <p:sp>
         <p:nvSpPr>
-          <p:cNvPr id="10" name="TextBox 9"/>
+          <p:cNvPr id="11" name="TextBox 10"/>
           <p:cNvSpPr txBox="1"/>
           <p:nvPr/>
         </p:nvSpPr>
@@ -5206,7 +5292,7 @@
             <a:pPr>
               <a:defRPr b="1" sz="850">
                 <a:solidFill>
-                  <a:srgbClr val="1F3A6E"/>
+                  <a:srgbClr val="A855F7"/>
                 </a:solidFill>
               </a:defRPr>
             </a:pPr>
@@ -5218,7 +5304,7 @@
             <a:pPr>
               <a:defRPr b="1" sz="1100">
                 <a:solidFill>
-                  <a:srgbClr val="0A192F"/>
+                  <a:srgbClr val="FFFFFF"/>
                 </a:solidFill>
               </a:defRPr>
             </a:pPr>
@@ -5230,7 +5316,7 @@
             <a:pPr>
               <a:defRPr sz="850">
                 <a:solidFill>
-                  <a:srgbClr val="0F172A"/>
+                  <a:srgbClr val="94A3B8"/>
                 </a:solidFill>
               </a:defRPr>
             </a:pPr>
@@ -5250,7 +5336,7 @@
       </p:sp>
       <p:sp>
         <p:nvSpPr>
-          <p:cNvPr id="11" name="Rounded Rectangle 10"/>
+          <p:cNvPr id="12" name="Rounded Rectangle 11"/>
           <p:cNvSpPr/>
           <p:nvPr/>
         </p:nvSpPr>
@@ -5263,11 +5349,11 @@
             <a:avLst/>
           </a:prstGeom>
           <a:solidFill>
-            <a:srgbClr val="F8FAFC"/>
+            <a:srgbClr val="172541"/>
           </a:solidFill>
           <a:ln w="22225">
             <a:solidFill>
-              <a:srgbClr val="059669"/>
+              <a:srgbClr val="10B981"/>
             </a:solidFill>
           </a:ln>
         </p:spPr>
@@ -5295,7 +5381,7 @@
       </p:sp>
       <p:sp>
         <p:nvSpPr>
-          <p:cNvPr id="12" name="TextBox 11"/>
+          <p:cNvPr id="13" name="TextBox 12"/>
           <p:cNvSpPr txBox="1"/>
           <p:nvPr/>
         </p:nvSpPr>
@@ -5318,7 +5404,7 @@
             <a:pPr>
               <a:defRPr b="1" sz="850">
                 <a:solidFill>
-                  <a:srgbClr val="059669"/>
+                  <a:srgbClr val="10B981"/>
                 </a:solidFill>
               </a:defRPr>
             </a:pPr>
@@ -5330,7 +5416,7 @@
             <a:pPr>
               <a:defRPr b="1" sz="1100">
                 <a:solidFill>
-                  <a:srgbClr val="0A192F"/>
+                  <a:srgbClr val="FFFFFF"/>
                 </a:solidFill>
               </a:defRPr>
             </a:pPr>
@@ -5342,7 +5428,7 @@
             <a:pPr>
               <a:defRPr sz="850">
                 <a:solidFill>
-                  <a:srgbClr val="0F172A"/>
+                  <a:srgbClr val="94A3B8"/>
                 </a:solidFill>
               </a:defRPr>
             </a:pPr>
@@ -5362,7 +5448,7 @@
       </p:sp>
       <p:sp>
         <p:nvSpPr>
-          <p:cNvPr id="13" name="Rounded Rectangle 12"/>
+          <p:cNvPr id="14" name="Rounded Rectangle 13"/>
           <p:cNvSpPr/>
           <p:nvPr/>
         </p:nvSpPr>
@@ -5375,11 +5461,11 @@
             <a:avLst/>
           </a:prstGeom>
           <a:solidFill>
-            <a:srgbClr val="F8FAFC"/>
+            <a:srgbClr val="172541"/>
           </a:solidFill>
           <a:ln w="22225">
             <a:solidFill>
-              <a:srgbClr val="D97706"/>
+              <a:srgbClr val="F59E0B"/>
             </a:solidFill>
           </a:ln>
         </p:spPr>
@@ -5407,7 +5493,7 @@
       </p:sp>
       <p:sp>
         <p:nvSpPr>
-          <p:cNvPr id="14" name="TextBox 13"/>
+          <p:cNvPr id="15" name="TextBox 14"/>
           <p:cNvSpPr txBox="1"/>
           <p:nvPr/>
         </p:nvSpPr>
@@ -5430,7 +5516,7 @@
             <a:pPr>
               <a:defRPr b="1" sz="850">
                 <a:solidFill>
-                  <a:srgbClr val="D97706"/>
+                  <a:srgbClr val="F59E0B"/>
                 </a:solidFill>
               </a:defRPr>
             </a:pPr>
@@ -5442,7 +5528,7 @@
             <a:pPr>
               <a:defRPr b="1" sz="1100">
                 <a:solidFill>
-                  <a:srgbClr val="0A192F"/>
+                  <a:srgbClr val="FFFFFF"/>
                 </a:solidFill>
               </a:defRPr>
             </a:pPr>
@@ -5454,7 +5540,7 @@
             <a:pPr>
               <a:defRPr sz="850">
                 <a:solidFill>
-                  <a:srgbClr val="0F172A"/>
+                  <a:srgbClr val="94A3B8"/>
                 </a:solidFill>
               </a:defRPr>
             </a:pPr>
@@ -5474,7 +5560,7 @@
       </p:sp>
       <p:sp>
         <p:nvSpPr>
-          <p:cNvPr id="15" name="Rounded Rectangle 14"/>
+          <p:cNvPr id="16" name="Rounded Rectangle 15"/>
           <p:cNvSpPr/>
           <p:nvPr/>
         </p:nvSpPr>
@@ -5487,11 +5573,11 @@
             <a:avLst/>
           </a:prstGeom>
           <a:solidFill>
-            <a:srgbClr val="0A192F"/>
+            <a:srgbClr val="0F1B30"/>
           </a:solidFill>
           <a:ln w="19050">
             <a:solidFill>
-              <a:srgbClr val="059669"/>
+              <a:srgbClr val="10B981"/>
             </a:solidFill>
           </a:ln>
         </p:spPr>
@@ -5519,7 +5605,7 @@
       </p:sp>
       <p:sp>
         <p:nvSpPr>
-          <p:cNvPr id="16" name="TextBox 15"/>
+          <p:cNvPr id="17" name="TextBox 16"/>
           <p:cNvSpPr txBox="1"/>
           <p:nvPr/>
         </p:nvSpPr>
@@ -5542,7 +5628,7 @@
             <a:pPr>
               <a:defRPr b="1" sz="1000">
                 <a:solidFill>
-                  <a:srgbClr val="059669"/>
+                  <a:srgbClr val="10B981"/>
                 </a:solidFill>
               </a:defRPr>
             </a:pPr>
@@ -5554,7 +5640,7 @@
             <a:pPr>
               <a:defRPr sz="900">
                 <a:solidFill>
-                  <a:srgbClr val="FFFFFF"/>
+                  <a:srgbClr val="F1F5F9"/>
                 </a:solidFill>
               </a:defRPr>
             </a:pPr>
@@ -5598,14 +5684,57 @@
         </p:nvSpPr>
         <p:spPr>
           <a:xfrm>
-            <a:off x="731520" y="365760"/>
-            <a:ext cx="10728655" cy="777240"/>
+            <a:off x="0" y="0"/>
+            <a:ext cx="12191695" cy="6858000"/>
           </a:xfrm>
           <a:prstGeom prst="rect">
             <a:avLst/>
           </a:prstGeom>
           <a:solidFill>
-            <a:srgbClr val="0A192F"/>
+            <a:srgbClr val="070F1E"/>
+          </a:solidFill>
+          <a:ln>
+            <a:noFill/>
+          </a:ln>
+        </p:spPr>
+        <p:style>
+          <a:lnRef idx="1">
+            <a:schemeClr val="accent1"/>
+          </a:lnRef>
+          <a:fillRef idx="3">
+            <a:schemeClr val="accent1"/>
+          </a:fillRef>
+          <a:effectRef idx="2">
+            <a:schemeClr val="accent1"/>
+          </a:effectRef>
+          <a:fontRef idx="minor">
+            <a:schemeClr val="lt1"/>
+          </a:fontRef>
+        </p:style>
+        <p:txBody>
+          <a:bodyPr rtlCol="0" anchor="ctr"/>
+          <a:lstStyle/>
+          <a:p>
+            <a:pPr algn="ctr"/>
+          </a:p>
+        </p:txBody>
+      </p:sp>
+      <p:sp>
+        <p:nvSpPr>
+          <p:cNvPr id="3" name="Rounded Rectangle 2"/>
+          <p:cNvSpPr/>
+          <p:nvPr/>
+        </p:nvSpPr>
+        <p:spPr>
+          <a:xfrm>
+            <a:off x="731520" y="320040"/>
+            <a:ext cx="10728655" cy="822960"/>
+          </a:xfrm>
+          <a:prstGeom prst="roundRect">
+            <a:avLst/>
+          </a:prstGeom>
+          <a:solidFill>
+            <a:srgbClr val="0F1B30"/>
           </a:solidFill>
           <a:ln w="19050">
             <a:solidFill>
@@ -5637,14 +5766,14 @@
       </p:sp>
       <p:sp>
         <p:nvSpPr>
-          <p:cNvPr id="3" name="TextBox 2"/>
+          <p:cNvPr id="4" name="TextBox 3"/>
           <p:cNvSpPr txBox="1"/>
           <p:nvPr/>
         </p:nvSpPr>
         <p:spPr>
           <a:xfrm>
-            <a:off x="914400" y="411480"/>
-            <a:ext cx="7772400" cy="685800"/>
+            <a:off x="914400" y="384048"/>
+            <a:ext cx="7772400" cy="713232"/>
           </a:xfrm>
           <a:prstGeom prst="rect">
             <a:avLst/>
@@ -5652,7 +5781,7 @@
           <a:noFill/>
         </p:spPr>
         <p:txBody>
-          <a:bodyPr wrap="none" lIns="0" tIns="0" rIns="0" bIns="0">
+          <a:bodyPr wrap="square" lIns="0" tIns="0" rIns="0" bIns="0">
             <a:spAutoFit/>
           </a:bodyPr>
           <a:lstStyle/>
@@ -5686,24 +5815,24 @@
       </p:sp>
       <p:sp>
         <p:nvSpPr>
-          <p:cNvPr id="4" name="Rounded Rectangle 3"/>
+          <p:cNvPr id="5" name="Rounded Rectangle 4"/>
           <p:cNvSpPr/>
           <p:nvPr/>
         </p:nvSpPr>
         <p:spPr>
           <a:xfrm>
-            <a:off x="8961120" y="502920"/>
-            <a:ext cx="2286000" cy="457200"/>
+            <a:off x="8961120" y="475488"/>
+            <a:ext cx="2286000" cy="475488"/>
           </a:xfrm>
           <a:prstGeom prst="roundRect">
             <a:avLst/>
           </a:prstGeom>
           <a:solidFill>
-            <a:srgbClr val="1F3A6E"/>
+            <a:srgbClr val="172541"/>
           </a:solidFill>
-          <a:ln>
+          <a:ln w="15875">
             <a:solidFill>
-              <a:srgbClr val="38BDF8"/>
+              <a:srgbClr val="F59E0B"/>
             </a:solidFill>
           </a:ln>
         </p:spPr>
@@ -5728,7 +5857,7 @@
             <a:pPr algn="ctr">
               <a:defRPr b="1" sz="900">
                 <a:solidFill>
-                  <a:srgbClr val="FFFFFF"/>
+                  <a:srgbClr val="F59E0B"/>
                 </a:solidFill>
               </a:defRPr>
             </a:pPr>
@@ -5740,7 +5869,7 @@
       </p:sp>
       <p:sp>
         <p:nvSpPr>
-          <p:cNvPr id="5" name="Rectangle 4"/>
+          <p:cNvPr id="6" name="Rectangle 5"/>
           <p:cNvSpPr/>
           <p:nvPr/>
         </p:nvSpPr>
@@ -5753,7 +5882,7 @@
             <a:avLst/>
           </a:prstGeom>
           <a:solidFill>
-            <a:srgbClr val="E2E8F0"/>
+            <a:srgbClr val="1E3A66"/>
           </a:solidFill>
           <a:ln>
             <a:noFill/>
@@ -5783,7 +5912,7 @@
       </p:sp>
       <p:sp>
         <p:nvSpPr>
-          <p:cNvPr id="6" name="TextBox 5"/>
+          <p:cNvPr id="7" name="TextBox 6"/>
           <p:cNvSpPr txBox="1"/>
           <p:nvPr/>
         </p:nvSpPr>
@@ -5806,20 +5935,20 @@
             <a:pPr>
               <a:defRPr sz="800">
                 <a:solidFill>
-                  <a:srgbClr val="64748B"/>
+                  <a:srgbClr val="94A3B8"/>
                 </a:solidFill>
                 <a:latin typeface="Calibri"/>
               </a:defRPr>
             </a:pPr>
             <a:r>
-              <a:t>INDRA SOVEREIGN ENGINEERING WORKBENCH • AIR-GAP ZERO-WAN AUDITED • SM-26117 • SLIDE 4 OF 6</a:t>
-            </a:r>
-          </a:p>
-        </p:txBody>
-      </p:sp>
-      <p:sp>
-        <p:nvSpPr>
-          <p:cNvPr id="7" name="Rounded Rectangle 6"/>
+              <a:t>INDRA SOVEREIGN WORKBENCH • AIR-GAP ZERO-WAN AUDITED • SM-26117 • SLIDE 4 OF 6</a:t>
+            </a:r>
+          </a:p>
+        </p:txBody>
+      </p:sp>
+      <p:sp>
+        <p:nvSpPr>
+          <p:cNvPr id="8" name="Rounded Rectangle 7"/>
           <p:cNvSpPr/>
           <p:nvPr/>
         </p:nvSpPr>
@@ -5832,11 +5961,11 @@
             <a:avLst/>
           </a:prstGeom>
           <a:solidFill>
-            <a:srgbClr val="F8FAFC"/>
+            <a:srgbClr val="172541"/>
           </a:solidFill>
-          <a:ln w="22225">
+          <a:ln w="19050">
             <a:solidFill>
-              <a:srgbClr val="059669"/>
+              <a:srgbClr val="10B981"/>
             </a:solidFill>
           </a:ln>
         </p:spPr>
@@ -5864,7 +5993,7 @@
       </p:sp>
       <p:sp>
         <p:nvSpPr>
-          <p:cNvPr id="8" name="TextBox 7"/>
+          <p:cNvPr id="9" name="TextBox 8"/>
           <p:cNvSpPr txBox="1"/>
           <p:nvPr/>
         </p:nvSpPr>
@@ -5887,7 +6016,7 @@
             <a:pPr>
               <a:defRPr b="1" sz="900">
                 <a:solidFill>
-                  <a:srgbClr val="64748B"/>
+                  <a:srgbClr val="10B981"/>
                 </a:solidFill>
               </a:defRPr>
             </a:pPr>
@@ -5897,9 +6026,9 @@
           </a:p>
           <a:p>
             <a:pPr>
-              <a:defRPr b="1" sz="1800">
-                <a:solidFill>
-                  <a:srgbClr val="059669"/>
+              <a:defRPr b="1" sz="1700">
+                <a:solidFill>
+                  <a:srgbClr val="FFFFFF"/>
                 </a:solidFill>
               </a:defRPr>
             </a:pPr>
@@ -5911,7 +6040,7 @@
             <a:pPr>
               <a:defRPr sz="850">
                 <a:solidFill>
-                  <a:srgbClr val="0F172A"/>
+                  <a:srgbClr val="94A3B8"/>
                 </a:solidFill>
               </a:defRPr>
             </a:pPr>
@@ -5923,7 +6052,7 @@
       </p:sp>
       <p:sp>
         <p:nvSpPr>
-          <p:cNvPr id="9" name="Rounded Rectangle 8"/>
+          <p:cNvPr id="10" name="Rounded Rectangle 9"/>
           <p:cNvSpPr/>
           <p:nvPr/>
         </p:nvSpPr>
@@ -5936,11 +6065,11 @@
             <a:avLst/>
           </a:prstGeom>
           <a:solidFill>
-            <a:srgbClr val="F8FAFC"/>
+            <a:srgbClr val="172541"/>
           </a:solidFill>
-          <a:ln w="22225">
+          <a:ln w="19050">
             <a:solidFill>
-              <a:srgbClr val="1F3A6E"/>
+              <a:srgbClr val="38BDF8"/>
             </a:solidFill>
           </a:ln>
         </p:spPr>
@@ -5968,7 +6097,7 @@
       </p:sp>
       <p:sp>
         <p:nvSpPr>
-          <p:cNvPr id="10" name="TextBox 9"/>
+          <p:cNvPr id="11" name="TextBox 10"/>
           <p:cNvSpPr txBox="1"/>
           <p:nvPr/>
         </p:nvSpPr>
@@ -5991,7 +6120,7 @@
             <a:pPr>
               <a:defRPr b="1" sz="900">
                 <a:solidFill>
-                  <a:srgbClr val="64748B"/>
+                  <a:srgbClr val="38BDF8"/>
                 </a:solidFill>
               </a:defRPr>
             </a:pPr>
@@ -6001,9 +6130,9 @@
           </a:p>
           <a:p>
             <a:pPr>
-              <a:defRPr b="1" sz="1800">
-                <a:solidFill>
-                  <a:srgbClr val="1F3A6E"/>
+              <a:defRPr b="1" sz="1700">
+                <a:solidFill>
+                  <a:srgbClr val="FFFFFF"/>
                 </a:solidFill>
               </a:defRPr>
             </a:pPr>
@@ -6015,7 +6144,7 @@
             <a:pPr>
               <a:defRPr sz="850">
                 <a:solidFill>
-                  <a:srgbClr val="0F172A"/>
+                  <a:srgbClr val="94A3B8"/>
                 </a:solidFill>
               </a:defRPr>
             </a:pPr>
@@ -6027,7 +6156,7 @@
       </p:sp>
       <p:sp>
         <p:nvSpPr>
-          <p:cNvPr id="11" name="Rounded Rectangle 10"/>
+          <p:cNvPr id="12" name="Rounded Rectangle 11"/>
           <p:cNvSpPr/>
           <p:nvPr/>
         </p:nvSpPr>
@@ -6040,11 +6169,11 @@
             <a:avLst/>
           </a:prstGeom>
           <a:solidFill>
-            <a:srgbClr val="F8FAFC"/>
+            <a:srgbClr val="172541"/>
           </a:solidFill>
-          <a:ln w="22225">
+          <a:ln w="19050">
             <a:solidFill>
-              <a:srgbClr val="D97706"/>
+              <a:srgbClr val="F59E0B"/>
             </a:solidFill>
           </a:ln>
         </p:spPr>
@@ -6072,7 +6201,7 @@
       </p:sp>
       <p:sp>
         <p:nvSpPr>
-          <p:cNvPr id="12" name="TextBox 11"/>
+          <p:cNvPr id="13" name="TextBox 12"/>
           <p:cNvSpPr txBox="1"/>
           <p:nvPr/>
         </p:nvSpPr>
@@ -6095,7 +6224,7 @@
             <a:pPr>
               <a:defRPr b="1" sz="900">
                 <a:solidFill>
-                  <a:srgbClr val="64748B"/>
+                  <a:srgbClr val="F59E0B"/>
                 </a:solidFill>
               </a:defRPr>
             </a:pPr>
@@ -6105,9 +6234,9 @@
           </a:p>
           <a:p>
             <a:pPr>
-              <a:defRPr b="1" sz="1800">
-                <a:solidFill>
-                  <a:srgbClr val="D97706"/>
+              <a:defRPr b="1" sz="1700">
+                <a:solidFill>
+                  <a:srgbClr val="FFFFFF"/>
                 </a:solidFill>
               </a:defRPr>
             </a:pPr>
@@ -6119,7 +6248,7 @@
             <a:pPr>
               <a:defRPr sz="850">
                 <a:solidFill>
-                  <a:srgbClr val="0F172A"/>
+                  <a:srgbClr val="94A3B8"/>
                 </a:solidFill>
               </a:defRPr>
             </a:pPr>
@@ -6131,7 +6260,7 @@
       </p:sp>
       <p:sp>
         <p:nvSpPr>
-          <p:cNvPr id="13" name="Rounded Rectangle 12"/>
+          <p:cNvPr id="14" name="Rounded Rectangle 13"/>
           <p:cNvSpPr/>
           <p:nvPr/>
         </p:nvSpPr>
@@ -6144,9 +6273,9 @@
             <a:avLst/>
           </a:prstGeom>
           <a:solidFill>
-            <a:srgbClr val="F8FAFC"/>
+            <a:srgbClr val="172541"/>
           </a:solidFill>
-          <a:ln w="22225">
+          <a:ln w="19050">
             <a:solidFill>
               <a:srgbClr val="38BDF8"/>
             </a:solidFill>
@@ -6176,7 +6305,7 @@
       </p:sp>
       <p:sp>
         <p:nvSpPr>
-          <p:cNvPr id="14" name="TextBox 13"/>
+          <p:cNvPr id="15" name="TextBox 14"/>
           <p:cNvSpPr txBox="1"/>
           <p:nvPr/>
         </p:nvSpPr>
@@ -6199,7 +6328,7 @@
             <a:pPr>
               <a:defRPr b="1" sz="900">
                 <a:solidFill>
-                  <a:srgbClr val="64748B"/>
+                  <a:srgbClr val="38BDF8"/>
                 </a:solidFill>
               </a:defRPr>
             </a:pPr>
@@ -6209,9 +6338,9 @@
           </a:p>
           <a:p>
             <a:pPr>
-              <a:defRPr b="1" sz="1800">
-                <a:solidFill>
-                  <a:srgbClr val="38BDF8"/>
+              <a:defRPr b="1" sz="1700">
+                <a:solidFill>
+                  <a:srgbClr val="FFFFFF"/>
                 </a:solidFill>
               </a:defRPr>
             </a:pPr>
@@ -6223,7 +6352,7 @@
             <a:pPr>
               <a:defRPr sz="850">
                 <a:solidFill>
-                  <a:srgbClr val="0F172A"/>
+                  <a:srgbClr val="94A3B8"/>
                 </a:solidFill>
               </a:defRPr>
             </a:pPr>
@@ -6235,7 +6364,7 @@
       </p:sp>
       <p:sp>
         <p:nvSpPr>
-          <p:cNvPr id="15" name="Rounded Rectangle 14"/>
+          <p:cNvPr id="16" name="Rounded Rectangle 15"/>
           <p:cNvSpPr/>
           <p:nvPr/>
         </p:nvSpPr>
@@ -6248,11 +6377,11 @@
             <a:avLst/>
           </a:prstGeom>
           <a:solidFill>
-            <a:srgbClr val="F8FAFC"/>
+            <a:srgbClr val="172541"/>
           </a:solidFill>
-          <a:ln w="22225">
+          <a:ln w="19050">
             <a:solidFill>
-              <a:srgbClr val="059669"/>
+              <a:srgbClr val="10B981"/>
             </a:solidFill>
           </a:ln>
         </p:spPr>
@@ -6280,7 +6409,7 @@
       </p:sp>
       <p:sp>
         <p:nvSpPr>
-          <p:cNvPr id="16" name="TextBox 15"/>
+          <p:cNvPr id="17" name="TextBox 16"/>
           <p:cNvSpPr txBox="1"/>
           <p:nvPr/>
         </p:nvSpPr>
@@ -6303,7 +6432,7 @@
             <a:pPr>
               <a:defRPr b="1" sz="900">
                 <a:solidFill>
-                  <a:srgbClr val="64748B"/>
+                  <a:srgbClr val="10B981"/>
                 </a:solidFill>
               </a:defRPr>
             </a:pPr>
@@ -6313,9 +6442,9 @@
           </a:p>
           <a:p>
             <a:pPr>
-              <a:defRPr b="1" sz="1800">
-                <a:solidFill>
-                  <a:srgbClr val="059669"/>
+              <a:defRPr b="1" sz="1700">
+                <a:solidFill>
+                  <a:srgbClr val="FFFFFF"/>
                 </a:solidFill>
               </a:defRPr>
             </a:pPr>
@@ -6327,7 +6456,7 @@
             <a:pPr>
               <a:defRPr sz="850">
                 <a:solidFill>
-                  <a:srgbClr val="0F172A"/>
+                  <a:srgbClr val="94A3B8"/>
                 </a:solidFill>
               </a:defRPr>
             </a:pPr>
@@ -6339,7 +6468,7 @@
       </p:sp>
       <p:sp>
         <p:nvSpPr>
-          <p:cNvPr id="17" name="Rounded Rectangle 16"/>
+          <p:cNvPr id="18" name="Rounded Rectangle 17"/>
           <p:cNvSpPr/>
           <p:nvPr/>
         </p:nvSpPr>
@@ -6352,11 +6481,11 @@
             <a:avLst/>
           </a:prstGeom>
           <a:solidFill>
-            <a:srgbClr val="F8FAFC"/>
+            <a:srgbClr val="172541"/>
           </a:solidFill>
-          <a:ln w="22225">
+          <a:ln w="19050">
             <a:solidFill>
-              <a:srgbClr val="1F3A6E"/>
+              <a:srgbClr val="F59E0B"/>
             </a:solidFill>
           </a:ln>
         </p:spPr>
@@ -6384,7 +6513,7 @@
       </p:sp>
       <p:sp>
         <p:nvSpPr>
-          <p:cNvPr id="18" name="TextBox 17"/>
+          <p:cNvPr id="19" name="TextBox 18"/>
           <p:cNvSpPr txBox="1"/>
           <p:nvPr/>
         </p:nvSpPr>
@@ -6407,7 +6536,7 @@
             <a:pPr>
               <a:defRPr b="1" sz="900">
                 <a:solidFill>
-                  <a:srgbClr val="64748B"/>
+                  <a:srgbClr val="F59E0B"/>
                 </a:solidFill>
               </a:defRPr>
             </a:pPr>
@@ -6417,9 +6546,9 @@
           </a:p>
           <a:p>
             <a:pPr>
-              <a:defRPr b="1" sz="1800">
-                <a:solidFill>
-                  <a:srgbClr val="1F3A6E"/>
+              <a:defRPr b="1" sz="1700">
+                <a:solidFill>
+                  <a:srgbClr val="FFFFFF"/>
                 </a:solidFill>
               </a:defRPr>
             </a:pPr>
@@ -6431,7 +6560,7 @@
             <a:pPr>
               <a:defRPr sz="850">
                 <a:solidFill>
-                  <a:srgbClr val="0F172A"/>
+                  <a:srgbClr val="94A3B8"/>
                 </a:solidFill>
               </a:defRPr>
             </a:pPr>
@@ -6467,14 +6596,57 @@
         </p:nvSpPr>
         <p:spPr>
           <a:xfrm>
-            <a:off x="731520" y="365760"/>
-            <a:ext cx="10728655" cy="777240"/>
+            <a:off x="0" y="0"/>
+            <a:ext cx="12191695" cy="6858000"/>
           </a:xfrm>
           <a:prstGeom prst="rect">
             <a:avLst/>
           </a:prstGeom>
           <a:solidFill>
-            <a:srgbClr val="0A192F"/>
+            <a:srgbClr val="070F1E"/>
+          </a:solidFill>
+          <a:ln>
+            <a:noFill/>
+          </a:ln>
+        </p:spPr>
+        <p:style>
+          <a:lnRef idx="1">
+            <a:schemeClr val="accent1"/>
+          </a:lnRef>
+          <a:fillRef idx="3">
+            <a:schemeClr val="accent1"/>
+          </a:fillRef>
+          <a:effectRef idx="2">
+            <a:schemeClr val="accent1"/>
+          </a:effectRef>
+          <a:fontRef idx="minor">
+            <a:schemeClr val="lt1"/>
+          </a:fontRef>
+        </p:style>
+        <p:txBody>
+          <a:bodyPr rtlCol="0" anchor="ctr"/>
+          <a:lstStyle/>
+          <a:p>
+            <a:pPr algn="ctr"/>
+          </a:p>
+        </p:txBody>
+      </p:sp>
+      <p:sp>
+        <p:nvSpPr>
+          <p:cNvPr id="3" name="Rounded Rectangle 2"/>
+          <p:cNvSpPr/>
+          <p:nvPr/>
+        </p:nvSpPr>
+        <p:spPr>
+          <a:xfrm>
+            <a:off x="731520" y="320040"/>
+            <a:ext cx="10728655" cy="822960"/>
+          </a:xfrm>
+          <a:prstGeom prst="roundRect">
+            <a:avLst/>
+          </a:prstGeom>
+          <a:solidFill>
+            <a:srgbClr val="0F1B30"/>
           </a:solidFill>
           <a:ln w="19050">
             <a:solidFill>
@@ -6506,14 +6678,14 @@
       </p:sp>
       <p:sp>
         <p:nvSpPr>
-          <p:cNvPr id="3" name="TextBox 2"/>
+          <p:cNvPr id="4" name="TextBox 3"/>
           <p:cNvSpPr txBox="1"/>
           <p:nvPr/>
         </p:nvSpPr>
         <p:spPr>
           <a:xfrm>
-            <a:off x="914400" y="411480"/>
-            <a:ext cx="7772400" cy="685800"/>
+            <a:off x="914400" y="384048"/>
+            <a:ext cx="7772400" cy="713232"/>
           </a:xfrm>
           <a:prstGeom prst="rect">
             <a:avLst/>
@@ -6521,7 +6693,7 @@
           <a:noFill/>
         </p:spPr>
         <p:txBody>
-          <a:bodyPr wrap="none" lIns="0" tIns="0" rIns="0" bIns="0">
+          <a:bodyPr wrap="square" lIns="0" tIns="0" rIns="0" bIns="0">
             <a:spAutoFit/>
           </a:bodyPr>
           <a:lstStyle/>
@@ -6555,24 +6727,24 @@
       </p:sp>
       <p:sp>
         <p:nvSpPr>
-          <p:cNvPr id="4" name="Rounded Rectangle 3"/>
+          <p:cNvPr id="5" name="Rounded Rectangle 4"/>
           <p:cNvSpPr/>
           <p:nvPr/>
         </p:nvSpPr>
         <p:spPr>
           <a:xfrm>
-            <a:off x="8961120" y="502920"/>
-            <a:ext cx="2286000" cy="457200"/>
+            <a:off x="8961120" y="475488"/>
+            <a:ext cx="2286000" cy="475488"/>
           </a:xfrm>
           <a:prstGeom prst="roundRect">
             <a:avLst/>
           </a:prstGeom>
           <a:solidFill>
-            <a:srgbClr val="1F3A6E"/>
+            <a:srgbClr val="172541"/>
           </a:solidFill>
-          <a:ln>
+          <a:ln w="15875">
             <a:solidFill>
-              <a:srgbClr val="38BDF8"/>
+              <a:srgbClr val="F59E0B"/>
             </a:solidFill>
           </a:ln>
         </p:spPr>
@@ -6597,7 +6769,7 @@
             <a:pPr algn="ctr">
               <a:defRPr b="1" sz="900">
                 <a:solidFill>
-                  <a:srgbClr val="FFFFFF"/>
+                  <a:srgbClr val="F59E0B"/>
                 </a:solidFill>
               </a:defRPr>
             </a:pPr>
@@ -6609,7 +6781,7 @@
       </p:sp>
       <p:sp>
         <p:nvSpPr>
-          <p:cNvPr id="5" name="Rectangle 4"/>
+          <p:cNvPr id="6" name="Rectangle 5"/>
           <p:cNvSpPr/>
           <p:nvPr/>
         </p:nvSpPr>
@@ -6622,7 +6794,7 @@
             <a:avLst/>
           </a:prstGeom>
           <a:solidFill>
-            <a:srgbClr val="E2E8F0"/>
+            <a:srgbClr val="1E3A66"/>
           </a:solidFill>
           <a:ln>
             <a:noFill/>
@@ -6652,7 +6824,7 @@
       </p:sp>
       <p:sp>
         <p:nvSpPr>
-          <p:cNvPr id="6" name="TextBox 5"/>
+          <p:cNvPr id="7" name="TextBox 6"/>
           <p:cNvSpPr txBox="1"/>
           <p:nvPr/>
         </p:nvSpPr>
@@ -6675,20 +6847,20 @@
             <a:pPr>
               <a:defRPr sz="800">
                 <a:solidFill>
-                  <a:srgbClr val="64748B"/>
+                  <a:srgbClr val="94A3B8"/>
                 </a:solidFill>
                 <a:latin typeface="Calibri"/>
               </a:defRPr>
             </a:pPr>
             <a:r>
-              <a:t>INDRA SOVEREIGN ENGINEERING WORKBENCH • AIR-GAP ZERO-WAN AUDITED • SM-26117 • SLIDE 5 OF 6</a:t>
-            </a:r>
-          </a:p>
-        </p:txBody>
-      </p:sp>
-      <p:sp>
-        <p:nvSpPr>
-          <p:cNvPr id="7" name="Rounded Rectangle 6"/>
+              <a:t>INDRA SOVEREIGN WORKBENCH • AIR-GAP ZERO-WAN AUDITED • SM-26117 • SLIDE 5 OF 6</a:t>
+            </a:r>
+          </a:p>
+        </p:txBody>
+      </p:sp>
+      <p:sp>
+        <p:nvSpPr>
+          <p:cNvPr id="8" name="Rounded Rectangle 7"/>
           <p:cNvSpPr/>
           <p:nvPr/>
         </p:nvSpPr>
@@ -6701,11 +6873,11 @@
             <a:avLst/>
           </a:prstGeom>
           <a:solidFill>
-            <a:srgbClr val="F8FAFC"/>
+            <a:srgbClr val="172541"/>
           </a:solidFill>
-          <a:ln w="22225">
+          <a:ln w="19050">
             <a:solidFill>
-              <a:srgbClr val="059669"/>
+              <a:srgbClr val="10B981"/>
             </a:solidFill>
           </a:ln>
         </p:spPr>
@@ -6733,7 +6905,7 @@
       </p:sp>
       <p:sp>
         <p:nvSpPr>
-          <p:cNvPr id="8" name="TextBox 7"/>
+          <p:cNvPr id="9" name="TextBox 8"/>
           <p:cNvSpPr txBox="1"/>
           <p:nvPr/>
         </p:nvSpPr>
@@ -6756,7 +6928,7 @@
             <a:pPr>
               <a:defRPr b="1" sz="900">
                 <a:solidFill>
-                  <a:srgbClr val="64748B"/>
+                  <a:srgbClr val="10B981"/>
                 </a:solidFill>
               </a:defRPr>
             </a:pPr>
@@ -6766,9 +6938,9 @@
           </a:p>
           <a:p>
             <a:pPr>
-              <a:defRPr b="1" sz="1800">
-                <a:solidFill>
-                  <a:srgbClr val="059669"/>
+              <a:defRPr b="1" sz="1700">
+                <a:solidFill>
+                  <a:srgbClr val="FFFFFF"/>
                 </a:solidFill>
               </a:defRPr>
             </a:pPr>
@@ -6780,7 +6952,7 @@
             <a:pPr>
               <a:defRPr sz="850">
                 <a:solidFill>
-                  <a:srgbClr val="0F172A"/>
+                  <a:srgbClr val="94A3B8"/>
                 </a:solidFill>
               </a:defRPr>
             </a:pPr>
@@ -6792,7 +6964,7 @@
       </p:sp>
       <p:sp>
         <p:nvSpPr>
-          <p:cNvPr id="9" name="Rounded Rectangle 8"/>
+          <p:cNvPr id="10" name="Rounded Rectangle 9"/>
           <p:cNvSpPr/>
           <p:nvPr/>
         </p:nvSpPr>
@@ -6805,7 +6977,319 @@
             <a:avLst/>
           </a:prstGeom>
           <a:solidFill>
-            <a:srgbClr val="F8FAFC"/>
+            <a:srgbClr val="172541"/>
+          </a:solidFill>
+          <a:ln w="19050">
+            <a:solidFill>
+              <a:srgbClr val="38BDF8"/>
+            </a:solidFill>
+          </a:ln>
+        </p:spPr>
+        <p:style>
+          <a:lnRef idx="1">
+            <a:schemeClr val="accent1"/>
+          </a:lnRef>
+          <a:fillRef idx="3">
+            <a:schemeClr val="accent1"/>
+          </a:fillRef>
+          <a:effectRef idx="2">
+            <a:schemeClr val="accent1"/>
+          </a:effectRef>
+          <a:fontRef idx="minor">
+            <a:schemeClr val="lt1"/>
+          </a:fontRef>
+        </p:style>
+        <p:txBody>
+          <a:bodyPr rtlCol="0" anchor="ctr"/>
+          <a:lstStyle/>
+          <a:p>
+            <a:pPr algn="ctr"/>
+          </a:p>
+        </p:txBody>
+      </p:sp>
+      <p:sp>
+        <p:nvSpPr>
+          <p:cNvPr id="11" name="TextBox 10"/>
+          <p:cNvSpPr txBox="1"/>
+          <p:nvPr/>
+        </p:nvSpPr>
+        <p:spPr>
+          <a:xfrm>
+            <a:off x="3566160" y="1435607"/>
+            <a:ext cx="2286000" cy="1243584"/>
+          </a:xfrm>
+          <a:prstGeom prst="rect">
+            <a:avLst/>
+          </a:prstGeom>
+          <a:noFill/>
+        </p:spPr>
+        <p:txBody>
+          <a:bodyPr wrap="square" lIns="0" tIns="0" rIns="0" bIns="0">
+            <a:spAutoFit/>
+          </a:bodyPr>
+          <a:lstStyle/>
+          <a:p>
+            <a:pPr>
+              <a:defRPr b="1" sz="900">
+                <a:solidFill>
+                  <a:srgbClr val="38BDF8"/>
+                </a:solidFill>
+              </a:defRPr>
+            </a:pPr>
+            <a:r>
+              <a:t>CLOUD API COSTS</a:t>
+            </a:r>
+          </a:p>
+          <a:p>
+            <a:pPr>
+              <a:defRPr b="1" sz="1700">
+                <a:solidFill>
+                  <a:srgbClr val="FFFFFF"/>
+                </a:solidFill>
+              </a:defRPr>
+            </a:pPr>
+            <a:r>
+              <a:t>₹0 SAVED</a:t>
+            </a:r>
+          </a:p>
+          <a:p>
+            <a:pPr>
+              <a:defRPr sz="850">
+                <a:solidFill>
+                  <a:srgbClr val="94A3B8"/>
+                </a:solidFill>
+              </a:defRPr>
+            </a:pPr>
+            <a:r>
+              <a:t>Zero external tokens; eliminates recurring cloud bills</a:t>
+            </a:r>
+          </a:p>
+        </p:txBody>
+      </p:sp>
+      <p:sp>
+        <p:nvSpPr>
+          <p:cNvPr id="12" name="Rounded Rectangle 11"/>
+          <p:cNvSpPr/>
+          <p:nvPr/>
+        </p:nvSpPr>
+        <p:spPr>
+          <a:xfrm>
+            <a:off x="6126480" y="1325880"/>
+            <a:ext cx="2560320" cy="1463040"/>
+          </a:xfrm>
+          <a:prstGeom prst="roundRect">
+            <a:avLst/>
+          </a:prstGeom>
+          <a:solidFill>
+            <a:srgbClr val="172541"/>
+          </a:solidFill>
+          <a:ln w="19050">
+            <a:solidFill>
+              <a:srgbClr val="A855F7"/>
+            </a:solidFill>
+          </a:ln>
+        </p:spPr>
+        <p:style>
+          <a:lnRef idx="1">
+            <a:schemeClr val="accent1"/>
+          </a:lnRef>
+          <a:fillRef idx="3">
+            <a:schemeClr val="accent1"/>
+          </a:fillRef>
+          <a:effectRef idx="2">
+            <a:schemeClr val="accent1"/>
+          </a:effectRef>
+          <a:fontRef idx="minor">
+            <a:schemeClr val="lt1"/>
+          </a:fontRef>
+        </p:style>
+        <p:txBody>
+          <a:bodyPr rtlCol="0" anchor="ctr"/>
+          <a:lstStyle/>
+          <a:p>
+            <a:pPr algn="ctr"/>
+          </a:p>
+        </p:txBody>
+      </p:sp>
+      <p:sp>
+        <p:nvSpPr>
+          <p:cNvPr id="13" name="TextBox 12"/>
+          <p:cNvSpPr txBox="1"/>
+          <p:nvPr/>
+        </p:nvSpPr>
+        <p:spPr>
+          <a:xfrm>
+            <a:off x="6263640" y="1435607"/>
+            <a:ext cx="2286000" cy="1243584"/>
+          </a:xfrm>
+          <a:prstGeom prst="rect">
+            <a:avLst/>
+          </a:prstGeom>
+          <a:noFill/>
+        </p:spPr>
+        <p:txBody>
+          <a:bodyPr wrap="square" lIns="0" tIns="0" rIns="0" bIns="0">
+            <a:spAutoFit/>
+          </a:bodyPr>
+          <a:lstStyle/>
+          <a:p>
+            <a:pPr>
+              <a:defRPr b="1" sz="900">
+                <a:solidFill>
+                  <a:srgbClr val="A855F7"/>
+                </a:solidFill>
+              </a:defRPr>
+            </a:pPr>
+            <a:r>
+              <a:t>AIR-GAP COMPLIANCE</a:t>
+            </a:r>
+          </a:p>
+          <a:p>
+            <a:pPr>
+              <a:defRPr b="1" sz="1700">
+                <a:solidFill>
+                  <a:srgbClr val="FFFFFF"/>
+                </a:solidFill>
+              </a:defRPr>
+            </a:pPr>
+            <a:r>
+              <a:t>100% ZERO-WAN</a:t>
+            </a:r>
+          </a:p>
+          <a:p>
+            <a:pPr>
+              <a:defRPr sz="850">
+                <a:solidFill>
+                  <a:srgbClr val="94A3B8"/>
+                </a:solidFill>
+              </a:defRPr>
+            </a:pPr>
+            <a:r>
+              <a:t>Meets Indian Ministry of Petroleum cybersecurity standards</a:t>
+            </a:r>
+          </a:p>
+        </p:txBody>
+      </p:sp>
+      <p:sp>
+        <p:nvSpPr>
+          <p:cNvPr id="14" name="Rounded Rectangle 13"/>
+          <p:cNvSpPr/>
+          <p:nvPr/>
+        </p:nvSpPr>
+        <p:spPr>
+          <a:xfrm>
+            <a:off x="8823960" y="1325880"/>
+            <a:ext cx="2560320" cy="1463040"/>
+          </a:xfrm>
+          <a:prstGeom prst="roundRect">
+            <a:avLst/>
+          </a:prstGeom>
+          <a:solidFill>
+            <a:srgbClr val="172541"/>
+          </a:solidFill>
+          <a:ln w="19050">
+            <a:solidFill>
+              <a:srgbClr val="10B981"/>
+            </a:solidFill>
+          </a:ln>
+        </p:spPr>
+        <p:style>
+          <a:lnRef idx="1">
+            <a:schemeClr val="accent1"/>
+          </a:lnRef>
+          <a:fillRef idx="3">
+            <a:schemeClr val="accent1"/>
+          </a:fillRef>
+          <a:effectRef idx="2">
+            <a:schemeClr val="accent1"/>
+          </a:effectRef>
+          <a:fontRef idx="minor">
+            <a:schemeClr val="lt1"/>
+          </a:fontRef>
+        </p:style>
+        <p:txBody>
+          <a:bodyPr rtlCol="0" anchor="ctr"/>
+          <a:lstStyle/>
+          <a:p>
+            <a:pPr algn="ctr"/>
+          </a:p>
+        </p:txBody>
+      </p:sp>
+      <p:sp>
+        <p:nvSpPr>
+          <p:cNvPr id="15" name="TextBox 14"/>
+          <p:cNvSpPr txBox="1"/>
+          <p:nvPr/>
+        </p:nvSpPr>
+        <p:spPr>
+          <a:xfrm>
+            <a:off x="8961120" y="1435607"/>
+            <a:ext cx="2286000" cy="1243584"/>
+          </a:xfrm>
+          <a:prstGeom prst="rect">
+            <a:avLst/>
+          </a:prstGeom>
+          <a:noFill/>
+        </p:spPr>
+        <p:txBody>
+          <a:bodyPr wrap="square" lIns="0" tIns="0" rIns="0" bIns="0">
+            <a:spAutoFit/>
+          </a:bodyPr>
+          <a:lstStyle/>
+          <a:p>
+            <a:pPr>
+              <a:defRPr b="1" sz="900">
+                <a:solidFill>
+                  <a:srgbClr val="10B981"/>
+                </a:solidFill>
+              </a:defRPr>
+            </a:pPr>
+            <a:r>
+              <a:t>MATH HALLUCINATION</a:t>
+            </a:r>
+          </a:p>
+          <a:p>
+            <a:pPr>
+              <a:defRPr b="1" sz="1700">
+                <a:solidFill>
+                  <a:srgbClr val="FFFFFF"/>
+                </a:solidFill>
+              </a:defRPr>
+            </a:pPr>
+            <a:r>
+              <a:t>0.0% DETERMINISTIC</a:t>
+            </a:r>
+          </a:p>
+          <a:p>
+            <a:pPr>
+              <a:defRPr sz="850">
+                <a:solidFill>
+                  <a:srgbClr val="94A3B8"/>
+                </a:solidFill>
+              </a:defRPr>
+            </a:pPr>
+            <a:r>
+              <a:t>AST verified calculations eliminate catastrophic pipe rupture risk</a:t>
+            </a:r>
+          </a:p>
+        </p:txBody>
+      </p:sp>
+      <p:sp>
+        <p:nvSpPr>
+          <p:cNvPr id="16" name="Rounded Rectangle 15"/>
+          <p:cNvSpPr/>
+          <p:nvPr/>
+        </p:nvSpPr>
+        <p:spPr>
+          <a:xfrm>
+            <a:off x="731520" y="3017520"/>
+            <a:ext cx="2560320" cy="3108960"/>
+          </a:xfrm>
+          <a:prstGeom prst="roundRect">
+            <a:avLst/>
+          </a:prstGeom>
+          <a:solidFill>
+            <a:srgbClr val="172541"/>
           </a:solidFill>
           <a:ln w="22225">
             <a:solidFill>
@@ -6837,14 +7321,14 @@
       </p:sp>
       <p:sp>
         <p:nvSpPr>
-          <p:cNvPr id="10" name="TextBox 9"/>
+          <p:cNvPr id="17" name="TextBox 16"/>
           <p:cNvSpPr txBox="1"/>
           <p:nvPr/>
         </p:nvSpPr>
         <p:spPr>
           <a:xfrm>
-            <a:off x="3566160" y="1435607"/>
-            <a:ext cx="2286000" cy="1243584"/>
+            <a:off x="841248" y="3108960"/>
+            <a:ext cx="2331720" cy="2926080"/>
           </a:xfrm>
           <a:prstGeom prst="rect">
             <a:avLst/>
@@ -6852,68 +7336,64 @@
           <a:noFill/>
         </p:spPr>
         <p:txBody>
-          <a:bodyPr wrap="square" lIns="0" tIns="0" rIns="0" bIns="0">
+          <a:bodyPr wrap="square">
             <a:spAutoFit/>
           </a:bodyPr>
           <a:lstStyle/>
           <a:p>
             <a:pPr>
-              <a:defRPr b="1" sz="900">
-                <a:solidFill>
-                  <a:srgbClr val="64748B"/>
-                </a:solidFill>
-              </a:defRPr>
-            </a:pPr>
-            <a:r>
-              <a:t>CLOUD API COSTS</a:t>
-            </a:r>
-          </a:p>
-          <a:p>
-            <a:pPr>
-              <a:defRPr b="1" sz="1800">
+              <a:defRPr b="1" sz="1000">
                 <a:solidFill>
                   <a:srgbClr val="38BDF8"/>
                 </a:solidFill>
               </a:defRPr>
             </a:pPr>
             <a:r>
-              <a:t>₹0 SAVED</a:t>
+              <a:t>Refinery Asset Integrity Engineers</a:t>
             </a:r>
           </a:p>
           <a:p>
             <a:pPr>
               <a:defRPr sz="850">
                 <a:solidFill>
-                  <a:srgbClr val="0F172A"/>
-                </a:solidFill>
-              </a:defRPr>
-            </a:pPr>
-            <a:r>
-              <a:t>Zero external tokens; eliminates recurring cloud bills</a:t>
-            </a:r>
-          </a:p>
-        </p:txBody>
-      </p:sp>
-      <p:sp>
-        <p:nvSpPr>
-          <p:cNvPr id="11" name="Rounded Rectangle 10"/>
+                  <a:srgbClr val="94A3B8"/>
+                </a:solidFill>
+              </a:defRPr>
+            </a:pPr>
+            <a:r>
+              <a:t>• Instant Ultrasonic NDT wall thickness &amp; RSL evaluations</a:t>
+            </a:r>
+            <a:br/>
+            <a:r>
+              <a:t>• ASME B31.3 §304.1.2 compliance matrices auto-generated</a:t>
+            </a:r>
+            <a:br/>
+            <a:r>
+              <a:t>• Replaces error-prone manual engineering spreadsheets</a:t>
+            </a:r>
+          </a:p>
+        </p:txBody>
+      </p:sp>
+      <p:sp>
+        <p:nvSpPr>
+          <p:cNvPr id="18" name="Rounded Rectangle 17"/>
           <p:cNvSpPr/>
           <p:nvPr/>
         </p:nvSpPr>
         <p:spPr>
           <a:xfrm>
-            <a:off x="6126480" y="1325880"/>
-            <a:ext cx="2560320" cy="1463040"/>
+            <a:off x="3429000" y="3017520"/>
+            <a:ext cx="2560320" cy="3108960"/>
           </a:xfrm>
           <a:prstGeom prst="roundRect">
             <a:avLst/>
           </a:prstGeom>
           <a:solidFill>
-            <a:srgbClr val="F8FAFC"/>
+            <a:srgbClr val="172541"/>
           </a:solidFill>
           <a:ln w="22225">
             <a:solidFill>
-              <a:srgbClr val="1F3A6E"/>
+              <a:srgbClr val="10B981"/>
             </a:solidFill>
           </a:ln>
         </p:spPr>
@@ -6941,14 +7421,14 @@
       </p:sp>
       <p:sp>
         <p:nvSpPr>
-          <p:cNvPr id="12" name="TextBox 11"/>
+          <p:cNvPr id="19" name="TextBox 18"/>
           <p:cNvSpPr txBox="1"/>
           <p:nvPr/>
         </p:nvSpPr>
         <p:spPr>
           <a:xfrm>
-            <a:off x="6263640" y="1435607"/>
-            <a:ext cx="2286000" cy="1243584"/>
+            <a:off x="3538728" y="3108960"/>
+            <a:ext cx="2331720" cy="2926080"/>
           </a:xfrm>
           <a:prstGeom prst="rect">
             <a:avLst/>
@@ -6956,68 +7436,64 @@
           <a:noFill/>
         </p:spPr>
         <p:txBody>
-          <a:bodyPr wrap="square" lIns="0" tIns="0" rIns="0" bIns="0">
+          <a:bodyPr wrap="square">
             <a:spAutoFit/>
           </a:bodyPr>
           <a:lstStyle/>
           <a:p>
             <a:pPr>
-              <a:defRPr b="1" sz="900">
-                <a:solidFill>
-                  <a:srgbClr val="64748B"/>
-                </a:solidFill>
-              </a:defRPr>
-            </a:pPr>
-            <a:r>
-              <a:t>AIR-GAP COMPLIANCE</a:t>
-            </a:r>
-          </a:p>
-          <a:p>
-            <a:pPr>
-              <a:defRPr b="1" sz="1800">
-                <a:solidFill>
-                  <a:srgbClr val="1F3A6E"/>
-                </a:solidFill>
-              </a:defRPr>
-            </a:pPr>
-            <a:r>
-              <a:t>100% ZERO-WAN</a:t>
+              <a:defRPr b="1" sz="1000">
+                <a:solidFill>
+                  <a:srgbClr val="10B981"/>
+                </a:solidFill>
+              </a:defRPr>
+            </a:pPr>
+            <a:r>
+              <a:t>Statutory Plant Superintendents</a:t>
             </a:r>
           </a:p>
           <a:p>
             <a:pPr>
               <a:defRPr sz="850">
                 <a:solidFill>
-                  <a:srgbClr val="0F172A"/>
-                </a:solidFill>
-              </a:defRPr>
-            </a:pPr>
-            <a:r>
-              <a:t>Meets Indian Ministry of Petroleum cybersecurity standards</a:t>
-            </a:r>
-          </a:p>
-        </p:txBody>
-      </p:sp>
-      <p:sp>
-        <p:nvSpPr>
-          <p:cNvPr id="13" name="Rounded Rectangle 12"/>
+                  <a:srgbClr val="94A3B8"/>
+                </a:solidFill>
+              </a:defRPr>
+            </a:pPr>
+            <a:r>
+              <a:t>• Board-ready 16:9 executive PowerPoint presentations</a:t>
+            </a:r>
+            <a:br/>
+            <a:r>
+              <a:t>• Pre-filled formal Word approval notes with sign-off blocks</a:t>
+            </a:r>
+            <a:br/>
+            <a:r>
+              <a:t>• Dual-key authorization workflow ensures legal compliance</a:t>
+            </a:r>
+          </a:p>
+        </p:txBody>
+      </p:sp>
+      <p:sp>
+        <p:nvSpPr>
+          <p:cNvPr id="20" name="Rounded Rectangle 19"/>
           <p:cNvSpPr/>
           <p:nvPr/>
         </p:nvSpPr>
         <p:spPr>
           <a:xfrm>
-            <a:off x="8823960" y="1325880"/>
-            <a:ext cx="2560320" cy="1463040"/>
+            <a:off x="6126480" y="3017520"/>
+            <a:ext cx="2560320" cy="3108960"/>
           </a:xfrm>
           <a:prstGeom prst="roundRect">
             <a:avLst/>
           </a:prstGeom>
           <a:solidFill>
-            <a:srgbClr val="F8FAFC"/>
+            <a:srgbClr val="172541"/>
           </a:solidFill>
           <a:ln w="22225">
             <a:solidFill>
-              <a:srgbClr val="059669"/>
+              <a:srgbClr val="A855F7"/>
             </a:solidFill>
           </a:ln>
         </p:spPr>
@@ -7045,14 +7521,14 @@
       </p:sp>
       <p:sp>
         <p:nvSpPr>
-          <p:cNvPr id="14" name="TextBox 13"/>
+          <p:cNvPr id="21" name="TextBox 20"/>
           <p:cNvSpPr txBox="1"/>
           <p:nvPr/>
         </p:nvSpPr>
         <p:spPr>
           <a:xfrm>
-            <a:off x="8961120" y="1435607"/>
-            <a:ext cx="2286000" cy="1243584"/>
+            <a:off x="6236208" y="3108960"/>
+            <a:ext cx="2331720" cy="2926080"/>
           </a:xfrm>
           <a:prstGeom prst="rect">
             <a:avLst/>
@@ -7060,68 +7536,64 @@
           <a:noFill/>
         </p:spPr>
         <p:txBody>
-          <a:bodyPr wrap="square" lIns="0" tIns="0" rIns="0" bIns="0">
+          <a:bodyPr wrap="square">
             <a:spAutoFit/>
           </a:bodyPr>
           <a:lstStyle/>
           <a:p>
             <a:pPr>
-              <a:defRPr b="1" sz="900">
-                <a:solidFill>
-                  <a:srgbClr val="64748B"/>
-                </a:solidFill>
-              </a:defRPr>
-            </a:pPr>
-            <a:r>
-              <a:t>MATH HALLUCINATION</a:t>
-            </a:r>
-          </a:p>
-          <a:p>
-            <a:pPr>
-              <a:defRPr b="1" sz="1800">
-                <a:solidFill>
-                  <a:srgbClr val="059669"/>
-                </a:solidFill>
-              </a:defRPr>
-            </a:pPr>
-            <a:r>
-              <a:t>0% DETERMINISTIC</a:t>
+              <a:defRPr b="1" sz="1000">
+                <a:solidFill>
+                  <a:srgbClr val="A855F7"/>
+                </a:solidFill>
+              </a:defRPr>
+            </a:pPr>
+            <a:r>
+              <a:t>PSU Safety &amp; Vigilance Auditors</a:t>
             </a:r>
           </a:p>
           <a:p>
             <a:pPr>
               <a:defRPr sz="850">
                 <a:solidFill>
-                  <a:srgbClr val="0F172A"/>
-                </a:solidFill>
-              </a:defRPr>
-            </a:pPr>
-            <a:r>
-              <a:t>AST verified calculations eliminate catastrophic pipe rupture risk</a:t>
-            </a:r>
-          </a:p>
-        </p:txBody>
-      </p:sp>
-      <p:sp>
-        <p:nvSpPr>
-          <p:cNvPr id="15" name="Rounded Rectangle 14"/>
+                  <a:srgbClr val="94A3B8"/>
+                </a:solidFill>
+              </a:defRPr>
+            </a:pPr>
+            <a:r>
+              <a:t>• Tamper-evident SHA-256 Merkle audit trail for every task</a:t>
+            </a:r>
+            <a:br/>
+            <a:r>
+              <a:t>• 100% provenance tracking of formulas, tools, and inputs</a:t>
+            </a:r>
+            <a:br/>
+            <a:r>
+              <a:t>• IEC 62443 / CMMC OT security compliance out-of-the-box</a:t>
+            </a:r>
+          </a:p>
+        </p:txBody>
+      </p:sp>
+      <p:sp>
+        <p:nvSpPr>
+          <p:cNvPr id="22" name="Rounded Rectangle 21"/>
           <p:cNvSpPr/>
           <p:nvPr/>
         </p:nvSpPr>
         <p:spPr>
           <a:xfrm>
-            <a:off x="731520" y="3017520"/>
+            <a:off x="8823960" y="3017520"/>
             <a:ext cx="2560320" cy="3108960"/>
           </a:xfrm>
           <a:prstGeom prst="roundRect">
             <a:avLst/>
           </a:prstGeom>
           <a:solidFill>
-            <a:srgbClr val="F8FAFC"/>
+            <a:srgbClr val="172541"/>
           </a:solidFill>
           <a:ln w="22225">
             <a:solidFill>
-              <a:srgbClr val="1F3A6E"/>
+              <a:srgbClr val="F59E0B"/>
             </a:solidFill>
           </a:ln>
         </p:spPr>
@@ -7149,13 +7621,13 @@
       </p:sp>
       <p:sp>
         <p:nvSpPr>
-          <p:cNvPr id="16" name="TextBox 15"/>
+          <p:cNvPr id="23" name="TextBox 22"/>
           <p:cNvSpPr txBox="1"/>
           <p:nvPr/>
         </p:nvSpPr>
         <p:spPr>
           <a:xfrm>
-            <a:off x="841248" y="3108960"/>
+            <a:off x="8933688" y="3108960"/>
             <a:ext cx="2331720" cy="2926080"/>
           </a:xfrm>
           <a:prstGeom prst="rect">
@@ -7172,319 +7644,19 @@
             <a:pPr>
               <a:defRPr b="1" sz="1000">
                 <a:solidFill>
-                  <a:srgbClr val="1F3A6E"/>
-                </a:solidFill>
-              </a:defRPr>
-            </a:pPr>
-            <a:r>
-              <a:t>Refinery Asset Integrity Engineers</a:t>
+                  <a:srgbClr val="F59E0B"/>
+                </a:solidFill>
+              </a:defRPr>
+            </a:pPr>
+            <a:r>
+              <a:t>Plant Operations &amp; Maintenance Teams</a:t>
             </a:r>
           </a:p>
           <a:p>
             <a:pPr>
               <a:defRPr sz="850">
                 <a:solidFill>
-                  <a:srgbClr val="0F172A"/>
-                </a:solidFill>
-              </a:defRPr>
-            </a:pPr>
-            <a:r>
-              <a:t>• Instant Ultrasonic NDT wall thickness &amp; RSL evaluations</a:t>
-            </a:r>
-            <a:br/>
-            <a:r>
-              <a:t>• ASME B31.3 §304.1.2 compliance matrices auto-generated</a:t>
-            </a:r>
-            <a:br/>
-            <a:r>
-              <a:t>• Replaces error-prone manual engineering spreadsheets</a:t>
-            </a:r>
-          </a:p>
-        </p:txBody>
-      </p:sp>
-      <p:sp>
-        <p:nvSpPr>
-          <p:cNvPr id="17" name="Rounded Rectangle 16"/>
-          <p:cNvSpPr/>
-          <p:nvPr/>
-        </p:nvSpPr>
-        <p:spPr>
-          <a:xfrm>
-            <a:off x="3429000" y="3017520"/>
-            <a:ext cx="2560320" cy="3108960"/>
-          </a:xfrm>
-          <a:prstGeom prst="roundRect">
-            <a:avLst/>
-          </a:prstGeom>
-          <a:solidFill>
-            <a:srgbClr val="F8FAFC"/>
-          </a:solidFill>
-          <a:ln w="22225">
-            <a:solidFill>
-              <a:srgbClr val="059669"/>
-            </a:solidFill>
-          </a:ln>
-        </p:spPr>
-        <p:style>
-          <a:lnRef idx="1">
-            <a:schemeClr val="accent1"/>
-          </a:lnRef>
-          <a:fillRef idx="3">
-            <a:schemeClr val="accent1"/>
-          </a:fillRef>
-          <a:effectRef idx="2">
-            <a:schemeClr val="accent1"/>
-          </a:effectRef>
-          <a:fontRef idx="minor">
-            <a:schemeClr val="lt1"/>
-          </a:fontRef>
-        </p:style>
-        <p:txBody>
-          <a:bodyPr rtlCol="0" anchor="ctr"/>
-          <a:lstStyle/>
-          <a:p>
-            <a:pPr algn="ctr"/>
-          </a:p>
-        </p:txBody>
-      </p:sp>
-      <p:sp>
-        <p:nvSpPr>
-          <p:cNvPr id="18" name="TextBox 17"/>
-          <p:cNvSpPr txBox="1"/>
-          <p:nvPr/>
-        </p:nvSpPr>
-        <p:spPr>
-          <a:xfrm>
-            <a:off x="3538728" y="3108960"/>
-            <a:ext cx="2331720" cy="2926080"/>
-          </a:xfrm>
-          <a:prstGeom prst="rect">
-            <a:avLst/>
-          </a:prstGeom>
-          <a:noFill/>
-        </p:spPr>
-        <p:txBody>
-          <a:bodyPr wrap="square">
-            <a:spAutoFit/>
-          </a:bodyPr>
-          <a:lstStyle/>
-          <a:p>
-            <a:pPr>
-              <a:defRPr b="1" sz="1000">
-                <a:solidFill>
-                  <a:srgbClr val="059669"/>
-                </a:solidFill>
-              </a:defRPr>
-            </a:pPr>
-            <a:r>
-              <a:t>Statutory Plant Superintendents</a:t>
-            </a:r>
-          </a:p>
-          <a:p>
-            <a:pPr>
-              <a:defRPr sz="850">
-                <a:solidFill>
-                  <a:srgbClr val="0F172A"/>
-                </a:solidFill>
-              </a:defRPr>
-            </a:pPr>
-            <a:r>
-              <a:t>• Board-ready 16:9 executive PowerPoint presentations</a:t>
-            </a:r>
-            <a:br/>
-            <a:r>
-              <a:t>• Pre-filled formal Word approval notes with sign-off blocks</a:t>
-            </a:r>
-            <a:br/>
-            <a:r>
-              <a:t>• Dual-key authorization workflow ensures legal compliance</a:t>
-            </a:r>
-          </a:p>
-        </p:txBody>
-      </p:sp>
-      <p:sp>
-        <p:nvSpPr>
-          <p:cNvPr id="19" name="Rounded Rectangle 18"/>
-          <p:cNvSpPr/>
-          <p:nvPr/>
-        </p:nvSpPr>
-        <p:spPr>
-          <a:xfrm>
-            <a:off x="6126480" y="3017520"/>
-            <a:ext cx="2560320" cy="3108960"/>
-          </a:xfrm>
-          <a:prstGeom prst="roundRect">
-            <a:avLst/>
-          </a:prstGeom>
-          <a:solidFill>
-            <a:srgbClr val="F8FAFC"/>
-          </a:solidFill>
-          <a:ln w="22225">
-            <a:solidFill>
-              <a:srgbClr val="38BDF8"/>
-            </a:solidFill>
-          </a:ln>
-        </p:spPr>
-        <p:style>
-          <a:lnRef idx="1">
-            <a:schemeClr val="accent1"/>
-          </a:lnRef>
-          <a:fillRef idx="3">
-            <a:schemeClr val="accent1"/>
-          </a:fillRef>
-          <a:effectRef idx="2">
-            <a:schemeClr val="accent1"/>
-          </a:effectRef>
-          <a:fontRef idx="minor">
-            <a:schemeClr val="lt1"/>
-          </a:fontRef>
-        </p:style>
-        <p:txBody>
-          <a:bodyPr rtlCol="0" anchor="ctr"/>
-          <a:lstStyle/>
-          <a:p>
-            <a:pPr algn="ctr"/>
-          </a:p>
-        </p:txBody>
-      </p:sp>
-      <p:sp>
-        <p:nvSpPr>
-          <p:cNvPr id="20" name="TextBox 19"/>
-          <p:cNvSpPr txBox="1"/>
-          <p:nvPr/>
-        </p:nvSpPr>
-        <p:spPr>
-          <a:xfrm>
-            <a:off x="6236208" y="3108960"/>
-            <a:ext cx="2331720" cy="2926080"/>
-          </a:xfrm>
-          <a:prstGeom prst="rect">
-            <a:avLst/>
-          </a:prstGeom>
-          <a:noFill/>
-        </p:spPr>
-        <p:txBody>
-          <a:bodyPr wrap="square">
-            <a:spAutoFit/>
-          </a:bodyPr>
-          <a:lstStyle/>
-          <a:p>
-            <a:pPr>
-              <a:defRPr b="1" sz="1000">
-                <a:solidFill>
-                  <a:srgbClr val="38BDF8"/>
-                </a:solidFill>
-              </a:defRPr>
-            </a:pPr>
-            <a:r>
-              <a:t>PSU Safety &amp; Vigilance Auditors</a:t>
-            </a:r>
-          </a:p>
-          <a:p>
-            <a:pPr>
-              <a:defRPr sz="850">
-                <a:solidFill>
-                  <a:srgbClr val="0F172A"/>
-                </a:solidFill>
-              </a:defRPr>
-            </a:pPr>
-            <a:r>
-              <a:t>• Tamper-evident SHA-256 Merkle audit trail for every task</a:t>
-            </a:r>
-            <a:br/>
-            <a:r>
-              <a:t>• 100% provenance tracking of formulas, tools, and inputs</a:t>
-            </a:r>
-            <a:br/>
-            <a:r>
-              <a:t>• IEC 62443 / CMMC OT security compliance out-of-the-box</a:t>
-            </a:r>
-          </a:p>
-        </p:txBody>
-      </p:sp>
-      <p:sp>
-        <p:nvSpPr>
-          <p:cNvPr id="21" name="Rounded Rectangle 20"/>
-          <p:cNvSpPr/>
-          <p:nvPr/>
-        </p:nvSpPr>
-        <p:spPr>
-          <a:xfrm>
-            <a:off x="8823960" y="3017520"/>
-            <a:ext cx="2560320" cy="3108960"/>
-          </a:xfrm>
-          <a:prstGeom prst="roundRect">
-            <a:avLst/>
-          </a:prstGeom>
-          <a:solidFill>
-            <a:srgbClr val="F8FAFC"/>
-          </a:solidFill>
-          <a:ln w="22225">
-            <a:solidFill>
-              <a:srgbClr val="D97706"/>
-            </a:solidFill>
-          </a:ln>
-        </p:spPr>
-        <p:style>
-          <a:lnRef idx="1">
-            <a:schemeClr val="accent1"/>
-          </a:lnRef>
-          <a:fillRef idx="3">
-            <a:schemeClr val="accent1"/>
-          </a:fillRef>
-          <a:effectRef idx="2">
-            <a:schemeClr val="accent1"/>
-          </a:effectRef>
-          <a:fontRef idx="minor">
-            <a:schemeClr val="lt1"/>
-          </a:fontRef>
-        </p:style>
-        <p:txBody>
-          <a:bodyPr rtlCol="0" anchor="ctr"/>
-          <a:lstStyle/>
-          <a:p>
-            <a:pPr algn="ctr"/>
-          </a:p>
-        </p:txBody>
-      </p:sp>
-      <p:sp>
-        <p:nvSpPr>
-          <p:cNvPr id="22" name="TextBox 21"/>
-          <p:cNvSpPr txBox="1"/>
-          <p:nvPr/>
-        </p:nvSpPr>
-        <p:spPr>
-          <a:xfrm>
-            <a:off x="8933688" y="3108960"/>
-            <a:ext cx="2331720" cy="2926080"/>
-          </a:xfrm>
-          <a:prstGeom prst="rect">
-            <a:avLst/>
-          </a:prstGeom>
-          <a:noFill/>
-        </p:spPr>
-        <p:txBody>
-          <a:bodyPr wrap="square">
-            <a:spAutoFit/>
-          </a:bodyPr>
-          <a:lstStyle/>
-          <a:p>
-            <a:pPr>
-              <a:defRPr b="1" sz="1000">
-                <a:solidFill>
-                  <a:srgbClr val="D97706"/>
-                </a:solidFill>
-              </a:defRPr>
-            </a:pPr>
-            <a:r>
-              <a:t>Plant Operations &amp; Maintenance Teams</a:t>
-            </a:r>
-          </a:p>
-          <a:p>
-            <a:pPr>
-              <a:defRPr sz="850">
-                <a:solidFill>
-                  <a:srgbClr val="0F172A"/>
+                  <a:srgbClr val="94A3B8"/>
                 </a:solidFill>
               </a:defRPr>
             </a:pPr>
@@ -7528,14 +7700,57 @@
         </p:nvSpPr>
         <p:spPr>
           <a:xfrm>
-            <a:off x="731520" y="365760"/>
-            <a:ext cx="10728655" cy="777240"/>
+            <a:off x="0" y="0"/>
+            <a:ext cx="12191695" cy="6858000"/>
           </a:xfrm>
           <a:prstGeom prst="rect">
             <a:avLst/>
           </a:prstGeom>
           <a:solidFill>
-            <a:srgbClr val="0A192F"/>
+            <a:srgbClr val="070F1E"/>
+          </a:solidFill>
+          <a:ln>
+            <a:noFill/>
+          </a:ln>
+        </p:spPr>
+        <p:style>
+          <a:lnRef idx="1">
+            <a:schemeClr val="accent1"/>
+          </a:lnRef>
+          <a:fillRef idx="3">
+            <a:schemeClr val="accent1"/>
+          </a:fillRef>
+          <a:effectRef idx="2">
+            <a:schemeClr val="accent1"/>
+          </a:effectRef>
+          <a:fontRef idx="minor">
+            <a:schemeClr val="lt1"/>
+          </a:fontRef>
+        </p:style>
+        <p:txBody>
+          <a:bodyPr rtlCol="0" anchor="ctr"/>
+          <a:lstStyle/>
+          <a:p>
+            <a:pPr algn="ctr"/>
+          </a:p>
+        </p:txBody>
+      </p:sp>
+      <p:sp>
+        <p:nvSpPr>
+          <p:cNvPr id="3" name="Rounded Rectangle 2"/>
+          <p:cNvSpPr/>
+          <p:nvPr/>
+        </p:nvSpPr>
+        <p:spPr>
+          <a:xfrm>
+            <a:off x="731520" y="320040"/>
+            <a:ext cx="10728655" cy="822960"/>
+          </a:xfrm>
+          <a:prstGeom prst="roundRect">
+            <a:avLst/>
+          </a:prstGeom>
+          <a:solidFill>
+            <a:srgbClr val="0F1B30"/>
           </a:solidFill>
           <a:ln w="19050">
             <a:solidFill>
@@ -7567,14 +7782,14 @@
       </p:sp>
       <p:sp>
         <p:nvSpPr>
-          <p:cNvPr id="3" name="TextBox 2"/>
+          <p:cNvPr id="4" name="TextBox 3"/>
           <p:cNvSpPr txBox="1"/>
           <p:nvPr/>
         </p:nvSpPr>
         <p:spPr>
           <a:xfrm>
-            <a:off x="914400" y="411480"/>
-            <a:ext cx="7772400" cy="685800"/>
+            <a:off x="914400" y="384048"/>
+            <a:ext cx="7772400" cy="713232"/>
           </a:xfrm>
           <a:prstGeom prst="rect">
             <a:avLst/>
@@ -7582,7 +7797,7 @@
           <a:noFill/>
         </p:spPr>
         <p:txBody>
-          <a:bodyPr wrap="none" lIns="0" tIns="0" rIns="0" bIns="0">
+          <a:bodyPr wrap="square" lIns="0" tIns="0" rIns="0" bIns="0">
             <a:spAutoFit/>
           </a:bodyPr>
           <a:lstStyle/>
@@ -7616,24 +7831,24 @@
       </p:sp>
       <p:sp>
         <p:nvSpPr>
-          <p:cNvPr id="4" name="Rounded Rectangle 3"/>
+          <p:cNvPr id="5" name="Rounded Rectangle 4"/>
           <p:cNvSpPr/>
           <p:nvPr/>
         </p:nvSpPr>
         <p:spPr>
           <a:xfrm>
-            <a:off x="8961120" y="502920"/>
-            <a:ext cx="2286000" cy="457200"/>
+            <a:off x="8961120" y="475488"/>
+            <a:ext cx="2286000" cy="475488"/>
           </a:xfrm>
           <a:prstGeom prst="roundRect">
             <a:avLst/>
           </a:prstGeom>
           <a:solidFill>
-            <a:srgbClr val="1F3A6E"/>
+            <a:srgbClr val="172541"/>
           </a:solidFill>
-          <a:ln>
+          <a:ln w="15875">
             <a:solidFill>
-              <a:srgbClr val="38BDF8"/>
+              <a:srgbClr val="F59E0B"/>
             </a:solidFill>
           </a:ln>
         </p:spPr>
@@ -7658,7 +7873,7 @@
             <a:pPr algn="ctr">
               <a:defRPr b="1" sz="900">
                 <a:solidFill>
-                  <a:srgbClr val="FFFFFF"/>
+                  <a:srgbClr val="F59E0B"/>
                 </a:solidFill>
               </a:defRPr>
             </a:pPr>
@@ -7670,7 +7885,7 @@
       </p:sp>
       <p:sp>
         <p:nvSpPr>
-          <p:cNvPr id="5" name="Rectangle 4"/>
+          <p:cNvPr id="6" name="Rectangle 5"/>
           <p:cNvSpPr/>
           <p:nvPr/>
         </p:nvSpPr>
@@ -7683,7 +7898,7 @@
             <a:avLst/>
           </a:prstGeom>
           <a:solidFill>
-            <a:srgbClr val="E2E8F0"/>
+            <a:srgbClr val="1E3A66"/>
           </a:solidFill>
           <a:ln>
             <a:noFill/>
@@ -7713,7 +7928,7 @@
       </p:sp>
       <p:sp>
         <p:nvSpPr>
-          <p:cNvPr id="6" name="TextBox 5"/>
+          <p:cNvPr id="7" name="TextBox 6"/>
           <p:cNvSpPr txBox="1"/>
           <p:nvPr/>
         </p:nvSpPr>
@@ -7736,20 +7951,20 @@
             <a:pPr>
               <a:defRPr sz="800">
                 <a:solidFill>
-                  <a:srgbClr val="64748B"/>
+                  <a:srgbClr val="94A3B8"/>
                 </a:solidFill>
                 <a:latin typeface="Calibri"/>
               </a:defRPr>
             </a:pPr>
             <a:r>
-              <a:t>INDRA SOVEREIGN ENGINEERING WORKBENCH • AIR-GAP ZERO-WAN AUDITED • SM-26117 • SLIDE 6 OF 6</a:t>
-            </a:r>
-          </a:p>
-        </p:txBody>
-      </p:sp>
-      <p:sp>
-        <p:nvSpPr>
-          <p:cNvPr id="7" name="Rounded Rectangle 6"/>
+              <a:t>INDRA SOVEREIGN WORKBENCH • AIR-GAP ZERO-WAN AUDITED • SM-26117 • SLIDE 6 OF 6</a:t>
+            </a:r>
+          </a:p>
+        </p:txBody>
+      </p:sp>
+      <p:sp>
+        <p:nvSpPr>
+          <p:cNvPr id="8" name="Rounded Rectangle 7"/>
           <p:cNvSpPr/>
           <p:nvPr/>
         </p:nvSpPr>
@@ -7762,245 +7977,7 @@
             <a:avLst/>
           </a:prstGeom>
           <a:solidFill>
-            <a:srgbClr val="F8FAFC"/>
-          </a:solidFill>
-          <a:ln w="22225">
-            <a:solidFill>
-              <a:srgbClr val="1F3A6E"/>
-            </a:solidFill>
-          </a:ln>
-        </p:spPr>
-        <p:style>
-          <a:lnRef idx="1">
-            <a:schemeClr val="accent1"/>
-          </a:lnRef>
-          <a:fillRef idx="3">
-            <a:schemeClr val="accent1"/>
-          </a:fillRef>
-          <a:effectRef idx="2">
-            <a:schemeClr val="accent1"/>
-          </a:effectRef>
-          <a:fontRef idx="minor">
-            <a:schemeClr val="lt1"/>
-          </a:fontRef>
-        </p:style>
-        <p:txBody>
-          <a:bodyPr rtlCol="0" anchor="ctr"/>
-          <a:lstStyle/>
-          <a:p>
-            <a:pPr algn="ctr"/>
-          </a:p>
-        </p:txBody>
-      </p:sp>
-      <p:sp>
-        <p:nvSpPr>
-          <p:cNvPr id="8" name="TextBox 7"/>
-          <p:cNvSpPr txBox="1"/>
-          <p:nvPr/>
-        </p:nvSpPr>
-        <p:spPr>
-          <a:xfrm>
-            <a:off x="914400" y="1417320"/>
-            <a:ext cx="4937760" cy="4572000"/>
-          </a:xfrm>
-          <a:prstGeom prst="rect">
-            <a:avLst/>
-          </a:prstGeom>
-          <a:noFill/>
-        </p:spPr>
-        <p:txBody>
-          <a:bodyPr wrap="square">
-            <a:spAutoFit/>
-          </a:bodyPr>
-          <a:lstStyle/>
-          <a:p>
-            <a:pPr>
-              <a:defRPr b="1" sz="1000">
-                <a:solidFill>
-                  <a:srgbClr val="1F3A6E"/>
-                </a:solidFill>
-              </a:defRPr>
-            </a:pPr>
-            <a:r>
-              <a:t>GOVERNING INDUSTRIAL STANDARDS &amp; SCIENTIFIC CODES</a:t>
-            </a:r>
-          </a:p>
-          <a:p>
-            <a:pPr>
-              <a:defRPr sz="850">
-                <a:solidFill>
-                  <a:srgbClr val="0F172A"/>
-                </a:solidFill>
-              </a:defRPr>
-            </a:pPr>
-            <a:r>
-              <a:t>• ASME B31.3 (2022 Edition): Process Piping Code §304.1.2 — Minimum Required Wall Thickness.</a:t>
-            </a:r>
-            <a:br/>
-            <a:br/>
-            <a:r>
-              <a:t>• API 570 (4th Edition): Piping Inspection Code: In-service Inspection, Rating, Repair &amp; Alteration.</a:t>
-            </a:r>
-            <a:br/>
-            <a:br/>
-            <a:r>
-              <a:t>• Crane Technical Paper No. 410 (TP 410): Flow of Fluids Through Valves, Fittings and Pipe.</a:t>
-            </a:r>
-            <a:br/>
-            <a:br/>
-            <a:r>
-              <a:t>• ISO 10816-3 (2009): Mechanical Vibration Evaluation on Industrial Machinery (Zones A/B/C/D).</a:t>
-            </a:r>
-            <a:br/>
-            <a:br/>
-            <a:r>
-              <a:t>• ANSI/ISA-5.1: Instrumentation Symbols and Identification for Piping &amp; Instrumentation Diagrams.</a:t>
-            </a:r>
-            <a:br/>
-            <a:br/>
-            <a:r>
-              <a:t>• API 610 (12th Edition) / ISO 13709: Centrifugal Pumps for Petroleum &amp; Gas Industries.</a:t>
-            </a:r>
-            <a:br/>
-            <a:br/>
-            <a:r>
-              <a:t>• Merkle, R. C. (1987): A Digital Signature Based on a Conventional Encryption Function (Merkle Trees).</a:t>
-            </a:r>
-          </a:p>
-        </p:txBody>
-      </p:sp>
-      <p:sp>
-        <p:nvSpPr>
-          <p:cNvPr id="9" name="Rounded Rectangle 8"/>
-          <p:cNvSpPr/>
-          <p:nvPr/>
-        </p:nvSpPr>
-        <p:spPr>
-          <a:xfrm>
-            <a:off x="6217920" y="1325880"/>
-            <a:ext cx="5212080" cy="1463040"/>
-          </a:xfrm>
-          <a:prstGeom prst="roundRect">
-            <a:avLst/>
-          </a:prstGeom>
-          <a:solidFill>
-            <a:srgbClr val="F8FAFC"/>
-          </a:solidFill>
-          <a:ln w="22225">
-            <a:solidFill>
-              <a:srgbClr val="059669"/>
-            </a:solidFill>
-          </a:ln>
-        </p:spPr>
-        <p:style>
-          <a:lnRef idx="1">
-            <a:schemeClr val="accent1"/>
-          </a:lnRef>
-          <a:fillRef idx="3">
-            <a:schemeClr val="accent1"/>
-          </a:fillRef>
-          <a:effectRef idx="2">
-            <a:schemeClr val="accent1"/>
-          </a:effectRef>
-          <a:fontRef idx="minor">
-            <a:schemeClr val="lt1"/>
-          </a:fontRef>
-        </p:style>
-        <p:txBody>
-          <a:bodyPr rtlCol="0" anchor="ctr"/>
-          <a:lstStyle/>
-          <a:p>
-            <a:pPr algn="ctr"/>
-          </a:p>
-        </p:txBody>
-      </p:sp>
-      <p:sp>
-        <p:nvSpPr>
-          <p:cNvPr id="10" name="TextBox 9"/>
-          <p:cNvSpPr txBox="1"/>
-          <p:nvPr/>
-        </p:nvSpPr>
-        <p:spPr>
-          <a:xfrm>
-            <a:off x="6355080" y="1417320"/>
-            <a:ext cx="4937760" cy="1280160"/>
-          </a:xfrm>
-          <a:prstGeom prst="rect">
-            <a:avLst/>
-          </a:prstGeom>
-          <a:noFill/>
-        </p:spPr>
-        <p:txBody>
-          <a:bodyPr wrap="square">
-            <a:spAutoFit/>
-          </a:bodyPr>
-          <a:lstStyle/>
-          <a:p>
-            <a:pPr>
-              <a:defRPr b="1" sz="850">
-                <a:solidFill>
-                  <a:srgbClr val="059669"/>
-                </a:solidFill>
-              </a:defRPr>
-            </a:pPr>
-            <a:r>
-              <a:t>PHASE 1: CURRENT (TRL 7)</a:t>
-            </a:r>
-          </a:p>
-          <a:p>
-            <a:pPr>
-              <a:defRPr b="1" sz="1050">
-                <a:solidFill>
-                  <a:srgbClr val="0A192F"/>
-                </a:solidFill>
-              </a:defRPr>
-            </a:pPr>
-            <a:r>
-              <a:t>Air-Gapped Desktop Prototype</a:t>
-            </a:r>
-          </a:p>
-          <a:p>
-            <a:pPr>
-              <a:defRPr sz="800">
-                <a:solidFill>
-                  <a:srgbClr val="0F172A"/>
-                </a:solidFill>
-              </a:defRPr>
-            </a:pPr>
-            <a:r>
-              <a:t>• Fully functional air-gapped workbench on local hardware</a:t>
-            </a:r>
-            <a:br/>
-            <a:r>
-              <a:t>• LangGraph DAG orchestrator with AST Python sandbox</a:t>
-            </a:r>
-            <a:br/>
-            <a:r>
-              <a:t>• Word (.docx), Excel (.xlsx), and 16:9 Deck (.pptx) factory</a:t>
-            </a:r>
-            <a:br/>
-            <a:r>
-              <a:t>• psutil socket auditor proving 0-WAN egress with SHA-256</a:t>
-            </a:r>
-          </a:p>
-        </p:txBody>
-      </p:sp>
-      <p:sp>
-        <p:nvSpPr>
-          <p:cNvPr id="11" name="Rounded Rectangle 10"/>
-          <p:cNvSpPr/>
-          <p:nvPr/>
-        </p:nvSpPr>
-        <p:spPr>
-          <a:xfrm>
-            <a:off x="6217920" y="2926080"/>
-            <a:ext cx="5212080" cy="1463040"/>
-          </a:xfrm>
-          <a:prstGeom prst="roundRect">
-            <a:avLst/>
-          </a:prstGeom>
-          <a:solidFill>
-            <a:srgbClr val="F8FAFC"/>
+            <a:srgbClr val="172541"/>
           </a:solidFill>
           <a:ln w="22225">
             <a:solidFill>
@@ -8032,14 +8009,14 @@
       </p:sp>
       <p:sp>
         <p:nvSpPr>
-          <p:cNvPr id="12" name="TextBox 11"/>
+          <p:cNvPr id="9" name="TextBox 8"/>
           <p:cNvSpPr txBox="1"/>
           <p:nvPr/>
         </p:nvSpPr>
         <p:spPr>
           <a:xfrm>
-            <a:off x="6355080" y="3017520"/>
-            <a:ext cx="4937760" cy="1280160"/>
+            <a:off x="914400" y="1417320"/>
+            <a:ext cx="4937760" cy="4572000"/>
           </a:xfrm>
           <a:prstGeom prst="rect">
             <a:avLst/>
@@ -8053,70 +8030,80 @@
           <a:lstStyle/>
           <a:p>
             <a:pPr>
-              <a:defRPr b="1" sz="850">
+              <a:defRPr b="1" sz="1000">
                 <a:solidFill>
                   <a:srgbClr val="38BDF8"/>
                 </a:solidFill>
               </a:defRPr>
             </a:pPr>
             <a:r>
-              <a:t>PHASE 2: NEAR-TERM (TRL 8)</a:t>
-            </a:r>
-          </a:p>
-          <a:p>
-            <a:pPr>
-              <a:defRPr b="1" sz="1050">
-                <a:solidFill>
-                  <a:srgbClr val="0A192F"/>
-                </a:solidFill>
-              </a:defRPr>
-            </a:pPr>
-            <a:r>
-              <a:t>SCADA / DCS Field Bus Integration</a:t>
-            </a:r>
-          </a:p>
-          <a:p>
-            <a:pPr>
-              <a:defRPr sz="800">
-                <a:solidFill>
-                  <a:srgbClr val="0F172A"/>
-                </a:solidFill>
-              </a:defRPr>
-            </a:pPr>
-            <a:r>
-              <a:t>• OPC-UA &amp; Modbus TCP connectors for real-time telemetry</a:t>
+              <a:t>GOVERNING INDUSTRIAL STANDARDS &amp; SCIENTIFIC CODES</a:t>
+            </a:r>
+          </a:p>
+          <a:p>
+            <a:pPr>
+              <a:defRPr sz="850">
+                <a:solidFill>
+                  <a:srgbClr val="94A3B8"/>
+                </a:solidFill>
+              </a:defRPr>
+            </a:pPr>
+            <a:r>
+              <a:t>• ASME B31.3 (2022 Edition): Process Piping Code §304.1.2 — Minimum Required Wall Thickness.</a:t>
             </a:r>
             <a:br/>
-            <a:r>
-              <a:t>• Multi-node distributed local LLM inference cluster</a:t>
-            </a:r>
             <a:br/>
             <a:r>
-              <a:t>• Direct CAD DXF/DWG vector blueprint extraction</a:t>
-            </a:r>
-          </a:p>
-        </p:txBody>
-      </p:sp>
-      <p:sp>
-        <p:nvSpPr>
-          <p:cNvPr id="13" name="Rounded Rectangle 12"/>
+              <a:t>• API 570 (4th Edition): Piping Inspection Code: In-service Inspection, Rating, Repair &amp; Alteration.</a:t>
+            </a:r>
+            <a:br/>
+            <a:br/>
+            <a:r>
+              <a:t>• Crane Technical Paper No. 410 (TP 410): Flow of Fluids Through Valves, Fittings and Pipe.</a:t>
+            </a:r>
+            <a:br/>
+            <a:br/>
+            <a:r>
+              <a:t>• ISO 10816-3 (2009): Mechanical Vibration Evaluation on Industrial Machinery (Zones A/B/C/D).</a:t>
+            </a:r>
+            <a:br/>
+            <a:br/>
+            <a:r>
+              <a:t>• ANSI/ISA-5.1: Instrumentation Symbols and Identification for Piping &amp; Instrumentation Diagrams.</a:t>
+            </a:r>
+            <a:br/>
+            <a:br/>
+            <a:r>
+              <a:t>• API 610 (12th Edition) / ISO 13709: Centrifugal Pumps for Petroleum &amp; Gas Industries.</a:t>
+            </a:r>
+            <a:br/>
+            <a:br/>
+            <a:r>
+              <a:t>• Merkle, R. C. (1987): A Digital Signature Based on a Conventional Encryption Function (Merkle Trees).</a:t>
+            </a:r>
+          </a:p>
+        </p:txBody>
+      </p:sp>
+      <p:sp>
+        <p:nvSpPr>
+          <p:cNvPr id="10" name="Rounded Rectangle 9"/>
           <p:cNvSpPr/>
           <p:nvPr/>
         </p:nvSpPr>
         <p:spPr>
           <a:xfrm>
-            <a:off x="6217920" y="4526280"/>
+            <a:off x="6217920" y="1325880"/>
             <a:ext cx="5212080" cy="1463040"/>
           </a:xfrm>
           <a:prstGeom prst="roundRect">
             <a:avLst/>
           </a:prstGeom>
           <a:solidFill>
-            <a:srgbClr val="F8FAFC"/>
+            <a:srgbClr val="172541"/>
           </a:solidFill>
           <a:ln w="22225">
             <a:solidFill>
-              <a:srgbClr val="1F3A6E"/>
+              <a:srgbClr val="10B981"/>
             </a:solidFill>
           </a:ln>
         </p:spPr>
@@ -8144,13 +8131,13 @@
       </p:sp>
       <p:sp>
         <p:nvSpPr>
-          <p:cNvPr id="14" name="TextBox 13"/>
+          <p:cNvPr id="11" name="TextBox 10"/>
           <p:cNvSpPr txBox="1"/>
           <p:nvPr/>
         </p:nvSpPr>
         <p:spPr>
           <a:xfrm>
-            <a:off x="6355080" y="4617720"/>
+            <a:off x="6355080" y="1417320"/>
             <a:ext cx="4937760" cy="1280160"/>
           </a:xfrm>
           <a:prstGeom prst="rect">
@@ -8167,7 +8154,235 @@
             <a:pPr>
               <a:defRPr b="1" sz="850">
                 <a:solidFill>
-                  <a:srgbClr val="1F3A6E"/>
+                  <a:srgbClr val="10B981"/>
+                </a:solidFill>
+              </a:defRPr>
+            </a:pPr>
+            <a:r>
+              <a:t>PHASE 1: CURRENT (TRL 7)</a:t>
+            </a:r>
+          </a:p>
+          <a:p>
+            <a:pPr>
+              <a:defRPr b="1" sz="1050">
+                <a:solidFill>
+                  <a:srgbClr val="FFFFFF"/>
+                </a:solidFill>
+              </a:defRPr>
+            </a:pPr>
+            <a:r>
+              <a:t>Air-Gapped Desktop Prototype</a:t>
+            </a:r>
+          </a:p>
+          <a:p>
+            <a:pPr>
+              <a:defRPr sz="800">
+                <a:solidFill>
+                  <a:srgbClr val="94A3B8"/>
+                </a:solidFill>
+              </a:defRPr>
+            </a:pPr>
+            <a:r>
+              <a:t>• Fully functional air-gapped workbench on local hardware</a:t>
+            </a:r>
+            <a:br/>
+            <a:r>
+              <a:t>• LangGraph DAG orchestrator with AST Python sandbox</a:t>
+            </a:r>
+            <a:br/>
+            <a:r>
+              <a:t>• Word (.docx), Excel (.xlsx), and 16:9 Deck (.pptx) factory</a:t>
+            </a:r>
+            <a:br/>
+            <a:r>
+              <a:t>• psutil socket auditor proving 0-WAN egress with SHA-256</a:t>
+            </a:r>
+          </a:p>
+        </p:txBody>
+      </p:sp>
+      <p:sp>
+        <p:nvSpPr>
+          <p:cNvPr id="12" name="Rounded Rectangle 11"/>
+          <p:cNvSpPr/>
+          <p:nvPr/>
+        </p:nvSpPr>
+        <p:spPr>
+          <a:xfrm>
+            <a:off x="6217920" y="2926080"/>
+            <a:ext cx="5212080" cy="1463040"/>
+          </a:xfrm>
+          <a:prstGeom prst="roundRect">
+            <a:avLst/>
+          </a:prstGeom>
+          <a:solidFill>
+            <a:srgbClr val="172541"/>
+          </a:solidFill>
+          <a:ln w="22225">
+            <a:solidFill>
+              <a:srgbClr val="38BDF8"/>
+            </a:solidFill>
+          </a:ln>
+        </p:spPr>
+        <p:style>
+          <a:lnRef idx="1">
+            <a:schemeClr val="accent1"/>
+          </a:lnRef>
+          <a:fillRef idx="3">
+            <a:schemeClr val="accent1"/>
+          </a:fillRef>
+          <a:effectRef idx="2">
+            <a:schemeClr val="accent1"/>
+          </a:effectRef>
+          <a:fontRef idx="minor">
+            <a:schemeClr val="lt1"/>
+          </a:fontRef>
+        </p:style>
+        <p:txBody>
+          <a:bodyPr rtlCol="0" anchor="ctr"/>
+          <a:lstStyle/>
+          <a:p>
+            <a:pPr algn="ctr"/>
+          </a:p>
+        </p:txBody>
+      </p:sp>
+      <p:sp>
+        <p:nvSpPr>
+          <p:cNvPr id="13" name="TextBox 12"/>
+          <p:cNvSpPr txBox="1"/>
+          <p:nvPr/>
+        </p:nvSpPr>
+        <p:spPr>
+          <a:xfrm>
+            <a:off x="6355080" y="3017520"/>
+            <a:ext cx="4937760" cy="1280160"/>
+          </a:xfrm>
+          <a:prstGeom prst="rect">
+            <a:avLst/>
+          </a:prstGeom>
+          <a:noFill/>
+        </p:spPr>
+        <p:txBody>
+          <a:bodyPr wrap="square">
+            <a:spAutoFit/>
+          </a:bodyPr>
+          <a:lstStyle/>
+          <a:p>
+            <a:pPr>
+              <a:defRPr b="1" sz="850">
+                <a:solidFill>
+                  <a:srgbClr val="38BDF8"/>
+                </a:solidFill>
+              </a:defRPr>
+            </a:pPr>
+            <a:r>
+              <a:t>PHASE 2: NEAR-TERM (TRL 8)</a:t>
+            </a:r>
+          </a:p>
+          <a:p>
+            <a:pPr>
+              <a:defRPr b="1" sz="1050">
+                <a:solidFill>
+                  <a:srgbClr val="FFFFFF"/>
+                </a:solidFill>
+              </a:defRPr>
+            </a:pPr>
+            <a:r>
+              <a:t>SCADA / DCS Field Bus Integration</a:t>
+            </a:r>
+          </a:p>
+          <a:p>
+            <a:pPr>
+              <a:defRPr sz="800">
+                <a:solidFill>
+                  <a:srgbClr val="94A3B8"/>
+                </a:solidFill>
+              </a:defRPr>
+            </a:pPr>
+            <a:r>
+              <a:t>• OPC-UA &amp; Modbus TCP connectors for real-time telemetry</a:t>
+            </a:r>
+            <a:br/>
+            <a:r>
+              <a:t>• Multi-node distributed local LLM inference cluster</a:t>
+            </a:r>
+            <a:br/>
+            <a:r>
+              <a:t>• Direct CAD DXF/DWG vector blueprint extraction</a:t>
+            </a:r>
+          </a:p>
+        </p:txBody>
+      </p:sp>
+      <p:sp>
+        <p:nvSpPr>
+          <p:cNvPr id="14" name="Rounded Rectangle 13"/>
+          <p:cNvSpPr/>
+          <p:nvPr/>
+        </p:nvSpPr>
+        <p:spPr>
+          <a:xfrm>
+            <a:off x="6217920" y="4526280"/>
+            <a:ext cx="5212080" cy="1463040"/>
+          </a:xfrm>
+          <a:prstGeom prst="roundRect">
+            <a:avLst/>
+          </a:prstGeom>
+          <a:solidFill>
+            <a:srgbClr val="172541"/>
+          </a:solidFill>
+          <a:ln w="22225">
+            <a:solidFill>
+              <a:srgbClr val="F59E0B"/>
+            </a:solidFill>
+          </a:ln>
+        </p:spPr>
+        <p:style>
+          <a:lnRef idx="1">
+            <a:schemeClr val="accent1"/>
+          </a:lnRef>
+          <a:fillRef idx="3">
+            <a:schemeClr val="accent1"/>
+          </a:fillRef>
+          <a:effectRef idx="2">
+            <a:schemeClr val="accent1"/>
+          </a:effectRef>
+          <a:fontRef idx="minor">
+            <a:schemeClr val="lt1"/>
+          </a:fontRef>
+        </p:style>
+        <p:txBody>
+          <a:bodyPr rtlCol="0" anchor="ctr"/>
+          <a:lstStyle/>
+          <a:p>
+            <a:pPr algn="ctr"/>
+          </a:p>
+        </p:txBody>
+      </p:sp>
+      <p:sp>
+        <p:nvSpPr>
+          <p:cNvPr id="15" name="TextBox 14"/>
+          <p:cNvSpPr txBox="1"/>
+          <p:nvPr/>
+        </p:nvSpPr>
+        <p:spPr>
+          <a:xfrm>
+            <a:off x="6355080" y="4617720"/>
+            <a:ext cx="4937760" cy="1280160"/>
+          </a:xfrm>
+          <a:prstGeom prst="rect">
+            <a:avLst/>
+          </a:prstGeom>
+          <a:noFill/>
+        </p:spPr>
+        <p:txBody>
+          <a:bodyPr wrap="square">
+            <a:spAutoFit/>
+          </a:bodyPr>
+          <a:lstStyle/>
+          <a:p>
+            <a:pPr>
+              <a:defRPr b="1" sz="850">
+                <a:solidFill>
+                  <a:srgbClr val="F59E0B"/>
                 </a:solidFill>
               </a:defRPr>
             </a:pPr>
@@ -8179,7 +8394,7 @@
             <a:pPr>
               <a:defRPr b="1" sz="1050">
                 <a:solidFill>
-                  <a:srgbClr val="0A192F"/>
+                  <a:srgbClr val="FFFFFF"/>
                 </a:solidFill>
               </a:defRPr>
             </a:pPr>
@@ -8191,7 +8406,7 @@
             <a:pPr>
               <a:defRPr sz="800">
                 <a:solidFill>
-                  <a:srgbClr val="0F172A"/>
+                  <a:srgbClr val="94A3B8"/>
                 </a:solidFill>
               </a:defRPr>
             </a:pPr>

</xml_diff>